<commit_message>
Fix MVP roadmap week ordering - resolve dependency gap
Week 2 Follow-Up Agent cannot work without Cause Classifier to know
which owner to contact. Reordered weeks to fix logical dependency:

- Week 1: Shadow Mode (Risk Detection only)
- Week 2: Root Cause Classification (Cause Classifier + RAG, advisory)
- Week 3: Automated Follow-Up (needs Week 2 classification output)
- Week 4: Optimization & Automation (Trade-Off Engine + actions)

Updated:
- Both presentation scripts with corrected week order
- PowerPoint Slide 5 MVP roadmap boxes
- Added clear gates for each week (precision, accuracy >80%, response >80%, OTIF improve)
</commit_message>
<xml_diff>
--- a/Agentic_AI_Delivery_Assurance_UPDATED_FINAL.pptx
+++ b/Agentic_AI_Delivery_Assurance_UPDATED_FINAL.pptx
@@ -130,7 +130,7 @@
 <file path=ppt/revisionInfo.xml><?xml version="1.0" encoding="utf-8"?>
 <p1510:revInfo xmlns:a="http://schemas.openxmlformats.org/drawingml/2006/main" xmlns:r="http://schemas.openxmlformats.org/officeDocument/2006/relationships" xmlns:p1510="http://schemas.microsoft.com/office/powerpoint/2015/10/main">
   <p1510:revLst>
-    <p1510:client id="{0C48753B-B11A-45D0-B7CE-DCB55416EB41}" v="21" dt="2026-05-09T17:34:25.939"/>
+    <p1510:client id="{B65C8A30-5CE5-4C10-9A35-4D6F639E3CB0}" v="14" dt="2026-05-12T04:45:39.699"/>
   </p1510:revLst>
 </p1510:revInfo>
 </file>
@@ -140,18 +140,18 @@
   <pc:docChgLst>
     <pc:chgData name="Rashmi Bhat Kekanaje" userId="33b2e9ea-e347-4a93-907a-aa92300ac3d3" providerId="ADAL" clId="{79AD01B1-C200-4FAB-8E05-6A4BF7F578BF}"/>
     <pc:docChg chg="undo custSel mod addSld delSld modSld modMainMaster">
-      <pc:chgData name="Rashmi Bhat Kekanaje" userId="33b2e9ea-e347-4a93-907a-aa92300ac3d3" providerId="ADAL" clId="{79AD01B1-C200-4FAB-8E05-6A4BF7F578BF}" dt="2026-05-10T08:31:01.272" v="291" actId="20577"/>
+      <pc:chgData name="Rashmi Bhat Kekanaje" userId="33b2e9ea-e347-4a93-907a-aa92300ac3d3" providerId="ADAL" clId="{79AD01B1-C200-4FAB-8E05-6A4BF7F578BF}" dt="2026-05-12T07:56:17.281" v="621" actId="1076"/>
       <pc:docMkLst>
         <pc:docMk/>
       </pc:docMkLst>
       <pc:sldChg chg="addSp delSp modSp mod">
-        <pc:chgData name="Rashmi Bhat Kekanaje" userId="33b2e9ea-e347-4a93-907a-aa92300ac3d3" providerId="ADAL" clId="{79AD01B1-C200-4FAB-8E05-6A4BF7F578BF}" dt="2026-05-09T17:32:58.805" v="225" actId="255"/>
+        <pc:chgData name="Rashmi Bhat Kekanaje" userId="33b2e9ea-e347-4a93-907a-aa92300ac3d3" providerId="ADAL" clId="{79AD01B1-C200-4FAB-8E05-6A4BF7F578BF}" dt="2026-05-12T05:33:08.411" v="421" actId="20577"/>
         <pc:sldMkLst>
           <pc:docMk/>
           <pc:sldMk cId="0" sldId="256"/>
         </pc:sldMkLst>
         <pc:spChg chg="mod">
-          <ac:chgData name="Rashmi Bhat Kekanaje" userId="33b2e9ea-e347-4a93-907a-aa92300ac3d3" providerId="ADAL" clId="{79AD01B1-C200-4FAB-8E05-6A4BF7F578BF}" dt="2026-05-09T17:30:53.345" v="203" actId="255"/>
+          <ac:chgData name="Rashmi Bhat Kekanaje" userId="33b2e9ea-e347-4a93-907a-aa92300ac3d3" providerId="ADAL" clId="{79AD01B1-C200-4FAB-8E05-6A4BF7F578BF}" dt="2026-05-11T15:32:31.447" v="294" actId="255"/>
           <ac:spMkLst>
             <pc:docMk/>
             <pc:sldMk cId="0" sldId="256"/>
@@ -159,7 +159,7 @@
           </ac:spMkLst>
         </pc:spChg>
         <pc:spChg chg="mod">
-          <ac:chgData name="Rashmi Bhat Kekanaje" userId="33b2e9ea-e347-4a93-907a-aa92300ac3d3" providerId="ADAL" clId="{79AD01B1-C200-4FAB-8E05-6A4BF7F578BF}" dt="2026-05-09T17:30:58.484" v="204" actId="255"/>
+          <ac:chgData name="Rashmi Bhat Kekanaje" userId="33b2e9ea-e347-4a93-907a-aa92300ac3d3" providerId="ADAL" clId="{79AD01B1-C200-4FAB-8E05-6A4BF7F578BF}" dt="2026-05-12T05:07:55.158" v="411" actId="20577"/>
           <ac:spMkLst>
             <pc:docMk/>
             <pc:sldMk cId="0" sldId="256"/>
@@ -174,32 +174,8 @@
             <ac:spMk id="13" creationId="{00000000-0000-0000-0000-000000000000}"/>
           </ac:spMkLst>
         </pc:spChg>
-        <pc:spChg chg="del">
-          <ac:chgData name="Rashmi Bhat Kekanaje" userId="33b2e9ea-e347-4a93-907a-aa92300ac3d3" providerId="ADAL" clId="{79AD01B1-C200-4FAB-8E05-6A4BF7F578BF}" dt="2026-05-09T17:31:58.894" v="214" actId="478"/>
-          <ac:spMkLst>
-            <pc:docMk/>
-            <pc:sldMk cId="0" sldId="256"/>
-            <ac:spMk id="14" creationId="{00000000-0000-0000-0000-000000000000}"/>
-          </ac:spMkLst>
-        </pc:spChg>
-        <pc:spChg chg="del">
-          <ac:chgData name="Rashmi Bhat Kekanaje" userId="33b2e9ea-e347-4a93-907a-aa92300ac3d3" providerId="ADAL" clId="{79AD01B1-C200-4FAB-8E05-6A4BF7F578BF}" dt="2026-05-09T17:32:13.562" v="217" actId="478"/>
-          <ac:spMkLst>
-            <pc:docMk/>
-            <pc:sldMk cId="0" sldId="256"/>
-            <ac:spMk id="15" creationId="{00000000-0000-0000-0000-000000000000}"/>
-          </ac:spMkLst>
-        </pc:spChg>
-        <pc:spChg chg="del">
-          <ac:chgData name="Rashmi Bhat Kekanaje" userId="33b2e9ea-e347-4a93-907a-aa92300ac3d3" providerId="ADAL" clId="{79AD01B1-C200-4FAB-8E05-6A4BF7F578BF}" dt="2026-05-09T17:32:22.494" v="220" actId="478"/>
-          <ac:spMkLst>
-            <pc:docMk/>
-            <pc:sldMk cId="0" sldId="256"/>
-            <ac:spMk id="16" creationId="{00000000-0000-0000-0000-000000000000}"/>
-          </ac:spMkLst>
-        </pc:spChg>
         <pc:spChg chg="mod">
-          <ac:chgData name="Rashmi Bhat Kekanaje" userId="33b2e9ea-e347-4a93-907a-aa92300ac3d3" providerId="ADAL" clId="{79AD01B1-C200-4FAB-8E05-6A4BF7F578BF}" dt="2026-05-09T17:31:04.703" v="205" actId="255"/>
+          <ac:chgData name="Rashmi Bhat Kekanaje" userId="33b2e9ea-e347-4a93-907a-aa92300ac3d3" providerId="ADAL" clId="{79AD01B1-C200-4FAB-8E05-6A4BF7F578BF}" dt="2026-05-12T05:33:08.411" v="421" actId="20577"/>
           <ac:spMkLst>
             <pc:docMk/>
             <pc:sldMk cId="0" sldId="256"/>
@@ -212,14 +188,6 @@
             <pc:docMk/>
             <pc:sldMk cId="0" sldId="256"/>
             <ac:spMk id="18" creationId="{00000000-0000-0000-0000-000000000000}"/>
-          </ac:spMkLst>
-        </pc:spChg>
-        <pc:spChg chg="add del">
-          <ac:chgData name="Rashmi Bhat Kekanaje" userId="33b2e9ea-e347-4a93-907a-aa92300ac3d3" providerId="ADAL" clId="{79AD01B1-C200-4FAB-8E05-6A4BF7F578BF}" dt="2026-05-09T17:31:25.924" v="207" actId="22"/>
-          <ac:spMkLst>
-            <pc:docMk/>
-            <pc:sldMk cId="0" sldId="256"/>
-            <ac:spMk id="20" creationId="{3EB681E8-3B32-AA67-3613-18DE6615DA9B}"/>
           </ac:spMkLst>
         </pc:spChg>
         <pc:spChg chg="add mod">
@@ -255,69 +223,14 @@
           </ac:spMkLst>
         </pc:spChg>
       </pc:sldChg>
-      <pc:sldChg chg="modSp del mod">
-        <pc:chgData name="Rashmi Bhat Kekanaje" userId="33b2e9ea-e347-4a93-907a-aa92300ac3d3" providerId="ADAL" clId="{79AD01B1-C200-4FAB-8E05-6A4BF7F578BF}" dt="2026-05-09T17:30:34.388" v="202" actId="2696"/>
-        <pc:sldMkLst>
-          <pc:docMk/>
-          <pc:sldMk cId="0" sldId="257"/>
-        </pc:sldMkLst>
-        <pc:spChg chg="mod">
-          <ac:chgData name="Rashmi Bhat Kekanaje" userId="33b2e9ea-e347-4a93-907a-aa92300ac3d3" providerId="ADAL" clId="{79AD01B1-C200-4FAB-8E05-6A4BF7F578BF}" dt="2026-05-09T17:13:09.613" v="175" actId="255"/>
-          <ac:spMkLst>
-            <pc:docMk/>
-            <pc:sldMk cId="0" sldId="257"/>
-            <ac:spMk id="4" creationId="{00000000-0000-0000-0000-000000000000}"/>
-          </ac:spMkLst>
-        </pc:spChg>
-        <pc:spChg chg="mod">
-          <ac:chgData name="Rashmi Bhat Kekanaje" userId="33b2e9ea-e347-4a93-907a-aa92300ac3d3" providerId="ADAL" clId="{79AD01B1-C200-4FAB-8E05-6A4BF7F578BF}" dt="2026-05-09T17:13:18.617" v="176" actId="255"/>
-          <ac:spMkLst>
-            <pc:docMk/>
-            <pc:sldMk cId="0" sldId="257"/>
-            <ac:spMk id="5" creationId="{00000000-0000-0000-0000-000000000000}"/>
-          </ac:spMkLst>
-        </pc:spChg>
-        <pc:spChg chg="mod">
-          <ac:chgData name="Rashmi Bhat Kekanaje" userId="33b2e9ea-e347-4a93-907a-aa92300ac3d3" providerId="ADAL" clId="{79AD01B1-C200-4FAB-8E05-6A4BF7F578BF}" dt="2026-05-09T17:12:49.612" v="173" actId="255"/>
-          <ac:spMkLst>
-            <pc:docMk/>
-            <pc:sldMk cId="0" sldId="257"/>
-            <ac:spMk id="6" creationId="{00000000-0000-0000-0000-000000000000}"/>
-          </ac:spMkLst>
-        </pc:spChg>
-        <pc:spChg chg="mod">
-          <ac:chgData name="Rashmi Bhat Kekanaje" userId="33b2e9ea-e347-4a93-907a-aa92300ac3d3" providerId="ADAL" clId="{79AD01B1-C200-4FAB-8E05-6A4BF7F578BF}" dt="2026-05-09T17:13:27.574" v="177" actId="255"/>
-          <ac:spMkLst>
-            <pc:docMk/>
-            <pc:sldMk cId="0" sldId="257"/>
-            <ac:spMk id="7" creationId="{00000000-0000-0000-0000-000000000000}"/>
-          </ac:spMkLst>
-        </pc:spChg>
-        <pc:spChg chg="mod">
-          <ac:chgData name="Rashmi Bhat Kekanaje" userId="33b2e9ea-e347-4a93-907a-aa92300ac3d3" providerId="ADAL" clId="{79AD01B1-C200-4FAB-8E05-6A4BF7F578BF}" dt="2026-05-09T17:13:35.410" v="178" actId="255"/>
-          <ac:spMkLst>
-            <pc:docMk/>
-            <pc:sldMk cId="0" sldId="257"/>
-            <ac:spMk id="8" creationId="{00000000-0000-0000-0000-000000000000}"/>
-          </ac:spMkLst>
-        </pc:spChg>
-        <pc:spChg chg="mod">
-          <ac:chgData name="Rashmi Bhat Kekanaje" userId="33b2e9ea-e347-4a93-907a-aa92300ac3d3" providerId="ADAL" clId="{79AD01B1-C200-4FAB-8E05-6A4BF7F578BF}" dt="2026-05-09T16:55:04.893" v="45" actId="20577"/>
-          <ac:spMkLst>
-            <pc:docMk/>
-            <pc:sldMk cId="0" sldId="257"/>
-            <ac:spMk id="9" creationId="{00000000-0000-0000-0000-000000000000}"/>
-          </ac:spMkLst>
-        </pc:spChg>
-      </pc:sldChg>
       <pc:sldChg chg="modSp mod">
-        <pc:chgData name="Rashmi Bhat Kekanaje" userId="33b2e9ea-e347-4a93-907a-aa92300ac3d3" providerId="ADAL" clId="{79AD01B1-C200-4FAB-8E05-6A4BF7F578BF}" dt="2026-05-10T08:31:01.272" v="291" actId="20577"/>
+        <pc:chgData name="Rashmi Bhat Kekanaje" userId="33b2e9ea-e347-4a93-907a-aa92300ac3d3" providerId="ADAL" clId="{79AD01B1-C200-4FAB-8E05-6A4BF7F578BF}" dt="2026-05-12T06:32:58.832" v="584" actId="20577"/>
         <pc:sldMkLst>
           <pc:docMk/>
           <pc:sldMk cId="0" sldId="258"/>
         </pc:sldMkLst>
         <pc:spChg chg="mod">
-          <ac:chgData name="Rashmi Bhat Kekanaje" userId="33b2e9ea-e347-4a93-907a-aa92300ac3d3" providerId="ADAL" clId="{79AD01B1-C200-4FAB-8E05-6A4BF7F578BF}" dt="2026-05-10T08:31:01.272" v="291" actId="20577"/>
+          <ac:chgData name="Rashmi Bhat Kekanaje" userId="33b2e9ea-e347-4a93-907a-aa92300ac3d3" providerId="ADAL" clId="{79AD01B1-C200-4FAB-8E05-6A4BF7F578BF}" dt="2026-05-12T06:32:58.832" v="584" actId="20577"/>
           <ac:spMkLst>
             <pc:docMk/>
             <pc:sldMk cId="0" sldId="258"/>
@@ -325,7 +238,7 @@
           </ac:spMkLst>
         </pc:spChg>
         <pc:spChg chg="mod">
-          <ac:chgData name="Rashmi Bhat Kekanaje" userId="33b2e9ea-e347-4a93-907a-aa92300ac3d3" providerId="ADAL" clId="{79AD01B1-C200-4FAB-8E05-6A4BF7F578BF}" dt="2026-05-09T17:41:03.519" v="271" actId="255"/>
+          <ac:chgData name="Rashmi Bhat Kekanaje" userId="33b2e9ea-e347-4a93-907a-aa92300ac3d3" providerId="ADAL" clId="{79AD01B1-C200-4FAB-8E05-6A4BF7F578BF}" dt="2026-05-12T04:43:50.659" v="326" actId="1076"/>
           <ac:spMkLst>
             <pc:docMk/>
             <pc:sldMk cId="0" sldId="258"/>
@@ -333,7 +246,7 @@
           </ac:spMkLst>
         </pc:spChg>
         <pc:spChg chg="mod">
-          <ac:chgData name="Rashmi Bhat Kekanaje" userId="33b2e9ea-e347-4a93-907a-aa92300ac3d3" providerId="ADAL" clId="{79AD01B1-C200-4FAB-8E05-6A4BF7F578BF}" dt="2026-05-09T17:40:56.627" v="270" actId="255"/>
+          <ac:chgData name="Rashmi Bhat Kekanaje" userId="33b2e9ea-e347-4a93-907a-aa92300ac3d3" providerId="ADAL" clId="{79AD01B1-C200-4FAB-8E05-6A4BF7F578BF}" dt="2026-05-12T04:43:56.366" v="327" actId="1076"/>
           <ac:spMkLst>
             <pc:docMk/>
             <pc:sldMk cId="0" sldId="258"/>
@@ -341,7 +254,7 @@
           </ac:spMkLst>
         </pc:spChg>
         <pc:spChg chg="mod">
-          <ac:chgData name="Rashmi Bhat Kekanaje" userId="33b2e9ea-e347-4a93-907a-aa92300ac3d3" providerId="ADAL" clId="{79AD01B1-C200-4FAB-8E05-6A4BF7F578BF}" dt="2026-05-09T17:43:15.114" v="288" actId="1076"/>
+          <ac:chgData name="Rashmi Bhat Kekanaje" userId="33b2e9ea-e347-4a93-907a-aa92300ac3d3" providerId="ADAL" clId="{79AD01B1-C200-4FAB-8E05-6A4BF7F578BF}" dt="2026-05-12T04:43:23.189" v="321" actId="1076"/>
           <ac:spMkLst>
             <pc:docMk/>
             <pc:sldMk cId="0" sldId="258"/>
@@ -358,7 +271,7 @@
         </pc:spChg>
       </pc:sldChg>
       <pc:sldChg chg="addSp delSp modSp mod">
-        <pc:chgData name="Rashmi Bhat Kekanaje" userId="33b2e9ea-e347-4a93-907a-aa92300ac3d3" providerId="ADAL" clId="{79AD01B1-C200-4FAB-8E05-6A4BF7F578BF}" dt="2026-05-09T17:41:29.050" v="274" actId="255"/>
+        <pc:chgData name="Rashmi Bhat Kekanaje" userId="33b2e9ea-e347-4a93-907a-aa92300ac3d3" providerId="ADAL" clId="{79AD01B1-C200-4FAB-8E05-6A4BF7F578BF}" dt="2026-05-12T04:44:21.977" v="328" actId="1076"/>
         <pc:sldMkLst>
           <pc:docMk/>
           <pc:sldMk cId="0" sldId="259"/>
@@ -372,23 +285,15 @@
           </ac:spMkLst>
         </pc:spChg>
         <pc:spChg chg="mod">
-          <ac:chgData name="Rashmi Bhat Kekanaje" userId="33b2e9ea-e347-4a93-907a-aa92300ac3d3" providerId="ADAL" clId="{79AD01B1-C200-4FAB-8E05-6A4BF7F578BF}" dt="2026-05-09T17:33:20.615" v="227" actId="255"/>
+          <ac:chgData name="Rashmi Bhat Kekanaje" userId="33b2e9ea-e347-4a93-907a-aa92300ac3d3" providerId="ADAL" clId="{79AD01B1-C200-4FAB-8E05-6A4BF7F578BF}" dt="2026-05-11T15:33:09.740" v="297" actId="255"/>
           <ac:spMkLst>
             <pc:docMk/>
             <pc:sldMk cId="0" sldId="259"/>
             <ac:spMk id="5" creationId="{00000000-0000-0000-0000-000000000000}"/>
           </ac:spMkLst>
         </pc:spChg>
-        <pc:spChg chg="del mod">
-          <ac:chgData name="Rashmi Bhat Kekanaje" userId="33b2e9ea-e347-4a93-907a-aa92300ac3d3" providerId="ADAL" clId="{79AD01B1-C200-4FAB-8E05-6A4BF7F578BF}" dt="2026-05-09T17:10:05.606" v="158" actId="478"/>
-          <ac:spMkLst>
-            <pc:docMk/>
-            <pc:sldMk cId="0" sldId="259"/>
-            <ac:spMk id="6" creationId="{00000000-0000-0000-0000-000000000000}"/>
-          </ac:spMkLst>
-        </pc:spChg>
         <pc:spChg chg="mod">
-          <ac:chgData name="Rashmi Bhat Kekanaje" userId="33b2e9ea-e347-4a93-907a-aa92300ac3d3" providerId="ADAL" clId="{79AD01B1-C200-4FAB-8E05-6A4BF7F578BF}" dt="2026-05-09T17:41:29.050" v="274" actId="255"/>
+          <ac:chgData name="Rashmi Bhat Kekanaje" userId="33b2e9ea-e347-4a93-907a-aa92300ac3d3" providerId="ADAL" clId="{79AD01B1-C200-4FAB-8E05-6A4BF7F578BF}" dt="2026-05-12T04:44:21.977" v="328" actId="1076"/>
           <ac:spMkLst>
             <pc:docMk/>
             <pc:sldMk cId="0" sldId="259"/>
@@ -401,14 +306,6 @@
             <pc:docMk/>
             <pc:sldMk cId="0" sldId="259"/>
             <ac:spMk id="8" creationId="{00000000-0000-0000-0000-000000000000}"/>
-          </ac:spMkLst>
-        </pc:spChg>
-        <pc:spChg chg="add del">
-          <ac:chgData name="Rashmi Bhat Kekanaje" userId="33b2e9ea-e347-4a93-907a-aa92300ac3d3" providerId="ADAL" clId="{79AD01B1-C200-4FAB-8E05-6A4BF7F578BF}" dt="2026-05-09T17:09:21.608" v="154" actId="22"/>
-          <ac:spMkLst>
-            <pc:docMk/>
-            <pc:sldMk cId="0" sldId="259"/>
-            <ac:spMk id="10" creationId="{96B3C1CC-FA30-B6D8-4BC8-23A58F1F55B3}"/>
           </ac:spMkLst>
         </pc:spChg>
         <pc:spChg chg="add mod">
@@ -428,87 +325,8 @@
           </ac:graphicFrameMkLst>
         </pc:graphicFrameChg>
       </pc:sldChg>
-      <pc:sldChg chg="modSp del mod">
-        <pc:chgData name="Rashmi Bhat Kekanaje" userId="33b2e9ea-e347-4a93-907a-aa92300ac3d3" providerId="ADAL" clId="{79AD01B1-C200-4FAB-8E05-6A4BF7F578BF}" dt="2026-05-09T17:34:42.801" v="235" actId="2696"/>
-        <pc:sldMkLst>
-          <pc:docMk/>
-          <pc:sldMk cId="0" sldId="260"/>
-        </pc:sldMkLst>
-        <pc:spChg chg="mod">
-          <ac:chgData name="Rashmi Bhat Kekanaje" userId="33b2e9ea-e347-4a93-907a-aa92300ac3d3" providerId="ADAL" clId="{79AD01B1-C200-4FAB-8E05-6A4BF7F578BF}" dt="2026-05-09T16:57:12.490" v="147" actId="255"/>
-          <ac:spMkLst>
-            <pc:docMk/>
-            <pc:sldMk cId="0" sldId="260"/>
-            <ac:spMk id="4" creationId="{00000000-0000-0000-0000-000000000000}"/>
-          </ac:spMkLst>
-        </pc:spChg>
-        <pc:spChg chg="mod">
-          <ac:chgData name="Rashmi Bhat Kekanaje" userId="33b2e9ea-e347-4a93-907a-aa92300ac3d3" providerId="ADAL" clId="{79AD01B1-C200-4FAB-8E05-6A4BF7F578BF}" dt="2026-05-09T16:56:40.154" v="143" actId="255"/>
-          <ac:spMkLst>
-            <pc:docMk/>
-            <pc:sldMk cId="0" sldId="260"/>
-            <ac:spMk id="6" creationId="{00000000-0000-0000-0000-000000000000}"/>
-          </ac:spMkLst>
-        </pc:spChg>
-        <pc:spChg chg="mod">
-          <ac:chgData name="Rashmi Bhat Kekanaje" userId="33b2e9ea-e347-4a93-907a-aa92300ac3d3" providerId="ADAL" clId="{79AD01B1-C200-4FAB-8E05-6A4BF7F578BF}" dt="2026-05-09T16:56:45.706" v="144" actId="255"/>
-          <ac:spMkLst>
-            <pc:docMk/>
-            <pc:sldMk cId="0" sldId="260"/>
-            <ac:spMk id="7" creationId="{00000000-0000-0000-0000-000000000000}"/>
-          </ac:spMkLst>
-        </pc:spChg>
-        <pc:spChg chg="mod">
-          <ac:chgData name="Rashmi Bhat Kekanaje" userId="33b2e9ea-e347-4a93-907a-aa92300ac3d3" providerId="ADAL" clId="{79AD01B1-C200-4FAB-8E05-6A4BF7F578BF}" dt="2026-05-09T16:56:55.588" v="145" actId="255"/>
-          <ac:spMkLst>
-            <pc:docMk/>
-            <pc:sldMk cId="0" sldId="260"/>
-            <ac:spMk id="8" creationId="{00000000-0000-0000-0000-000000000000}"/>
-          </ac:spMkLst>
-        </pc:spChg>
-        <pc:spChg chg="mod">
-          <ac:chgData name="Rashmi Bhat Kekanaje" userId="33b2e9ea-e347-4a93-907a-aa92300ac3d3" providerId="ADAL" clId="{79AD01B1-C200-4FAB-8E05-6A4BF7F578BF}" dt="2026-05-09T16:57:02.292" v="146" actId="255"/>
-          <ac:spMkLst>
-            <pc:docMk/>
-            <pc:sldMk cId="0" sldId="260"/>
-            <ac:spMk id="9" creationId="{00000000-0000-0000-0000-000000000000}"/>
-          </ac:spMkLst>
-        </pc:spChg>
-        <pc:spChg chg="mod">
-          <ac:chgData name="Rashmi Bhat Kekanaje" userId="33b2e9ea-e347-4a93-907a-aa92300ac3d3" providerId="ADAL" clId="{79AD01B1-C200-4FAB-8E05-6A4BF7F578BF}" dt="2026-05-09T17:34:12.628" v="233" actId="255"/>
-          <ac:spMkLst>
-            <pc:docMk/>
-            <pc:sldMk cId="0" sldId="260"/>
-            <ac:spMk id="10" creationId="{00000000-0000-0000-0000-000000000000}"/>
-          </ac:spMkLst>
-        </pc:spChg>
-        <pc:spChg chg="mod">
-          <ac:chgData name="Rashmi Bhat Kekanaje" userId="33b2e9ea-e347-4a93-907a-aa92300ac3d3" providerId="ADAL" clId="{79AD01B1-C200-4FAB-8E05-6A4BF7F578BF}" dt="2026-05-09T17:34:04.552" v="232" actId="255"/>
-          <ac:spMkLst>
-            <pc:docMk/>
-            <pc:sldMk cId="0" sldId="260"/>
-            <ac:spMk id="11" creationId="{00000000-0000-0000-0000-000000000000}"/>
-          </ac:spMkLst>
-        </pc:spChg>
-        <pc:spChg chg="mod">
-          <ac:chgData name="Rashmi Bhat Kekanaje" userId="33b2e9ea-e347-4a93-907a-aa92300ac3d3" providerId="ADAL" clId="{79AD01B1-C200-4FAB-8E05-6A4BF7F578BF}" dt="2026-05-09T17:33:58.970" v="231" actId="255"/>
-          <ac:spMkLst>
-            <pc:docMk/>
-            <pc:sldMk cId="0" sldId="260"/>
-            <ac:spMk id="12" creationId="{00000000-0000-0000-0000-000000000000}"/>
-          </ac:spMkLst>
-        </pc:spChg>
-        <pc:spChg chg="mod">
-          <ac:chgData name="Rashmi Bhat Kekanaje" userId="33b2e9ea-e347-4a93-907a-aa92300ac3d3" providerId="ADAL" clId="{79AD01B1-C200-4FAB-8E05-6A4BF7F578BF}" dt="2026-05-09T16:55:50.777" v="138" actId="20577"/>
-          <ac:spMkLst>
-            <pc:docMk/>
-            <pc:sldMk cId="0" sldId="260"/>
-            <ac:spMk id="13" creationId="{00000000-0000-0000-0000-000000000000}"/>
-          </ac:spMkLst>
-        </pc:spChg>
-      </pc:sldChg>
       <pc:sldChg chg="modSp add mod">
-        <pc:chgData name="Rashmi Bhat Kekanaje" userId="33b2e9ea-e347-4a93-907a-aa92300ac3d3" providerId="ADAL" clId="{79AD01B1-C200-4FAB-8E05-6A4BF7F578BF}" dt="2026-05-09T17:40:39.608" v="268" actId="255"/>
+        <pc:chgData name="Rashmi Bhat Kekanaje" userId="33b2e9ea-e347-4a93-907a-aa92300ac3d3" providerId="ADAL" clId="{79AD01B1-C200-4FAB-8E05-6A4BF7F578BF}" dt="2026-05-12T06:26:00.144" v="553" actId="14734"/>
         <pc:sldMkLst>
           <pc:docMk/>
           <pc:sldMk cId="0" sldId="261"/>
@@ -570,7 +388,7 @@
           </ac:spMkLst>
         </pc:spChg>
         <pc:spChg chg="mod">
-          <ac:chgData name="Rashmi Bhat Kekanaje" userId="33b2e9ea-e347-4a93-907a-aa92300ac3d3" providerId="ADAL" clId="{79AD01B1-C200-4FAB-8E05-6A4BF7F578BF}" dt="2026-05-09T17:40:39.608" v="268" actId="255"/>
+          <ac:chgData name="Rashmi Bhat Kekanaje" userId="33b2e9ea-e347-4a93-907a-aa92300ac3d3" providerId="ADAL" clId="{79AD01B1-C200-4FAB-8E05-6A4BF7F578BF}" dt="2026-05-12T06:01:30.260" v="519" actId="1076"/>
           <ac:spMkLst>
             <pc:docMk/>
             <pc:sldMk cId="0" sldId="261"/>
@@ -578,7 +396,7 @@
           </ac:spMkLst>
         </pc:spChg>
         <pc:spChg chg="mod">
-          <ac:chgData name="Rashmi Bhat Kekanaje" userId="33b2e9ea-e347-4a93-907a-aa92300ac3d3" providerId="ADAL" clId="{79AD01B1-C200-4FAB-8E05-6A4BF7F578BF}" dt="2026-05-09T17:38:14.727" v="261" actId="255"/>
+          <ac:chgData name="Rashmi Bhat Kekanaje" userId="33b2e9ea-e347-4a93-907a-aa92300ac3d3" providerId="ADAL" clId="{79AD01B1-C200-4FAB-8E05-6A4BF7F578BF}" dt="2026-05-12T06:00:59.860" v="517" actId="1076"/>
           <ac:spMkLst>
             <pc:docMk/>
             <pc:sldMk cId="0" sldId="261"/>
@@ -586,7 +404,7 @@
           </ac:spMkLst>
         </pc:spChg>
         <pc:spChg chg="mod">
-          <ac:chgData name="Rashmi Bhat Kekanaje" userId="33b2e9ea-e347-4a93-907a-aa92300ac3d3" providerId="ADAL" clId="{79AD01B1-C200-4FAB-8E05-6A4BF7F578BF}" dt="2026-05-09T17:38:37.373" v="264" actId="1076"/>
+          <ac:chgData name="Rashmi Bhat Kekanaje" userId="33b2e9ea-e347-4a93-907a-aa92300ac3d3" providerId="ADAL" clId="{79AD01B1-C200-4FAB-8E05-6A4BF7F578BF}" dt="2026-05-12T06:08:10.011" v="552" actId="20577"/>
           <ac:spMkLst>
             <pc:docMk/>
             <pc:sldMk cId="0" sldId="261"/>
@@ -594,7 +412,7 @@
           </ac:spMkLst>
         </pc:spChg>
         <pc:spChg chg="mod">
-          <ac:chgData name="Rashmi Bhat Kekanaje" userId="33b2e9ea-e347-4a93-907a-aa92300ac3d3" providerId="ADAL" clId="{79AD01B1-C200-4FAB-8E05-6A4BF7F578BF}" dt="2026-05-09T17:38:45.406" v="265" actId="1076"/>
+          <ac:chgData name="Rashmi Bhat Kekanaje" userId="33b2e9ea-e347-4a93-907a-aa92300ac3d3" providerId="ADAL" clId="{79AD01B1-C200-4FAB-8E05-6A4BF7F578BF}" dt="2026-05-12T06:00:51.393" v="516" actId="1076"/>
           <ac:spMkLst>
             <pc:docMk/>
             <pc:sldMk cId="0" sldId="261"/>
@@ -602,7 +420,7 @@
           </ac:spMkLst>
         </pc:spChg>
         <pc:graphicFrameChg chg="mod modGraphic">
-          <ac:chgData name="Rashmi Bhat Kekanaje" userId="33b2e9ea-e347-4a93-907a-aa92300ac3d3" providerId="ADAL" clId="{79AD01B1-C200-4FAB-8E05-6A4BF7F578BF}" dt="2026-05-09T17:29:59.666" v="197" actId="1076"/>
+          <ac:chgData name="Rashmi Bhat Kekanaje" userId="33b2e9ea-e347-4a93-907a-aa92300ac3d3" providerId="ADAL" clId="{79AD01B1-C200-4FAB-8E05-6A4BF7F578BF}" dt="2026-05-12T06:26:00.144" v="553" actId="14734"/>
           <ac:graphicFrameMkLst>
             <pc:docMk/>
             <pc:sldMk cId="0" sldId="261"/>
@@ -611,13 +429,21 @@
         </pc:graphicFrameChg>
       </pc:sldChg>
       <pc:sldChg chg="delSp modSp add del mod">
-        <pc:chgData name="Rashmi Bhat Kekanaje" userId="33b2e9ea-e347-4a93-907a-aa92300ac3d3" providerId="ADAL" clId="{79AD01B1-C200-4FAB-8E05-6A4BF7F578BF}" dt="2026-05-10T08:29:59.580" v="290" actId="20577"/>
+        <pc:chgData name="Rashmi Bhat Kekanaje" userId="33b2e9ea-e347-4a93-907a-aa92300ac3d3" providerId="ADAL" clId="{79AD01B1-C200-4FAB-8E05-6A4BF7F578BF}" dt="2026-05-12T07:56:17.281" v="621" actId="1076"/>
         <pc:sldMkLst>
           <pc:docMk/>
           <pc:sldMk cId="0" sldId="262"/>
         </pc:sldMkLst>
         <pc:spChg chg="mod">
-          <ac:chgData name="Rashmi Bhat Kekanaje" userId="33b2e9ea-e347-4a93-907a-aa92300ac3d3" providerId="ADAL" clId="{79AD01B1-C200-4FAB-8E05-6A4BF7F578BF}" dt="2026-05-09T17:42:35.257" v="283" actId="255"/>
+          <ac:chgData name="Rashmi Bhat Kekanaje" userId="33b2e9ea-e347-4a93-907a-aa92300ac3d3" providerId="ADAL" clId="{79AD01B1-C200-4FAB-8E05-6A4BF7F578BF}" dt="2026-05-11T15:34:55.441" v="310" actId="1076"/>
+          <ac:spMkLst>
+            <pc:docMk/>
+            <pc:sldMk cId="0" sldId="262"/>
+            <ac:spMk id="4" creationId="{00000000-0000-0000-0000-000000000000}"/>
+          </ac:spMkLst>
+        </pc:spChg>
+        <pc:spChg chg="mod">
+          <ac:chgData name="Rashmi Bhat Kekanaje" userId="33b2e9ea-e347-4a93-907a-aa92300ac3d3" providerId="ADAL" clId="{79AD01B1-C200-4FAB-8E05-6A4BF7F578BF}" dt="2026-05-11T15:35:41.416" v="316" actId="1076"/>
           <ac:spMkLst>
             <pc:docMk/>
             <pc:sldMk cId="0" sldId="262"/>
@@ -625,7 +451,7 @@
           </ac:spMkLst>
         </pc:spChg>
         <pc:spChg chg="mod">
-          <ac:chgData name="Rashmi Bhat Kekanaje" userId="33b2e9ea-e347-4a93-907a-aa92300ac3d3" providerId="ADAL" clId="{79AD01B1-C200-4FAB-8E05-6A4BF7F578BF}" dt="2026-05-09T17:42:40.483" v="284" actId="255"/>
+          <ac:chgData name="Rashmi Bhat Kekanaje" userId="33b2e9ea-e347-4a93-907a-aa92300ac3d3" providerId="ADAL" clId="{79AD01B1-C200-4FAB-8E05-6A4BF7F578BF}" dt="2026-05-11T15:35:27.648" v="315" actId="1076"/>
           <ac:spMkLst>
             <pc:docMk/>
             <pc:sldMk cId="0" sldId="262"/>
@@ -633,7 +459,7 @@
           </ac:spMkLst>
         </pc:spChg>
         <pc:spChg chg="mod">
-          <ac:chgData name="Rashmi Bhat Kekanaje" userId="33b2e9ea-e347-4a93-907a-aa92300ac3d3" providerId="ADAL" clId="{79AD01B1-C200-4FAB-8E05-6A4BF7F578BF}" dt="2026-05-09T17:42:45.626" v="285" actId="255"/>
+          <ac:chgData name="Rashmi Bhat Kekanaje" userId="33b2e9ea-e347-4a93-907a-aa92300ac3d3" providerId="ADAL" clId="{79AD01B1-C200-4FAB-8E05-6A4BF7F578BF}" dt="2026-05-11T15:35:22.935" v="314" actId="1076"/>
           <ac:spMkLst>
             <pc:docMk/>
             <pc:sldMk cId="0" sldId="262"/>
@@ -641,7 +467,15 @@
           </ac:spMkLst>
         </pc:spChg>
         <pc:spChg chg="mod">
-          <ac:chgData name="Rashmi Bhat Kekanaje" userId="33b2e9ea-e347-4a93-907a-aa92300ac3d3" providerId="ADAL" clId="{79AD01B1-C200-4FAB-8E05-6A4BF7F578BF}" dt="2026-05-09T17:36:09.061" v="243" actId="255"/>
+          <ac:chgData name="Rashmi Bhat Kekanaje" userId="33b2e9ea-e347-4a93-907a-aa92300ac3d3" providerId="ADAL" clId="{79AD01B1-C200-4FAB-8E05-6A4BF7F578BF}" dt="2026-05-11T15:34:47.051" v="309" actId="1076"/>
+          <ac:spMkLst>
+            <pc:docMk/>
+            <pc:sldMk cId="0" sldId="262"/>
+            <ac:spMk id="8" creationId="{00000000-0000-0000-0000-000000000000}"/>
+          </ac:spMkLst>
+        </pc:spChg>
+        <pc:spChg chg="mod">
+          <ac:chgData name="Rashmi Bhat Kekanaje" userId="33b2e9ea-e347-4a93-907a-aa92300ac3d3" providerId="ADAL" clId="{79AD01B1-C200-4FAB-8E05-6A4BF7F578BF}" dt="2026-05-11T15:34:23.165" v="305" actId="1076"/>
           <ac:spMkLst>
             <pc:docMk/>
             <pc:sldMk cId="0" sldId="262"/>
@@ -649,7 +483,7 @@
           </ac:spMkLst>
         </pc:spChg>
         <pc:spChg chg="mod">
-          <ac:chgData name="Rashmi Bhat Kekanaje" userId="33b2e9ea-e347-4a93-907a-aa92300ac3d3" providerId="ADAL" clId="{79AD01B1-C200-4FAB-8E05-6A4BF7F578BF}" dt="2026-05-09T17:36:14.697" v="244" actId="255"/>
+          <ac:chgData name="Rashmi Bhat Kekanaje" userId="33b2e9ea-e347-4a93-907a-aa92300ac3d3" providerId="ADAL" clId="{79AD01B1-C200-4FAB-8E05-6A4BF7F578BF}" dt="2026-05-12T07:56:00.985" v="619" actId="113"/>
           <ac:spMkLst>
             <pc:docMk/>
             <pc:sldMk cId="0" sldId="262"/>
@@ -657,7 +491,7 @@
           </ac:spMkLst>
         </pc:spChg>
         <pc:spChg chg="mod">
-          <ac:chgData name="Rashmi Bhat Kekanaje" userId="33b2e9ea-e347-4a93-907a-aa92300ac3d3" providerId="ADAL" clId="{79AD01B1-C200-4FAB-8E05-6A4BF7F578BF}" dt="2026-05-09T17:36:20.125" v="245" actId="255"/>
+          <ac:chgData name="Rashmi Bhat Kekanaje" userId="33b2e9ea-e347-4a93-907a-aa92300ac3d3" providerId="ADAL" clId="{79AD01B1-C200-4FAB-8E05-6A4BF7F578BF}" dt="2026-05-12T07:55:41.629" v="617" actId="207"/>
           <ac:spMkLst>
             <pc:docMk/>
             <pc:sldMk cId="0" sldId="262"/>
@@ -665,7 +499,7 @@
           </ac:spMkLst>
         </pc:spChg>
         <pc:spChg chg="mod">
-          <ac:chgData name="Rashmi Bhat Kekanaje" userId="33b2e9ea-e347-4a93-907a-aa92300ac3d3" providerId="ADAL" clId="{79AD01B1-C200-4FAB-8E05-6A4BF7F578BF}" dt="2026-05-09T17:36:26.004" v="246" actId="255"/>
+          <ac:chgData name="Rashmi Bhat Kekanaje" userId="33b2e9ea-e347-4a93-907a-aa92300ac3d3" providerId="ADAL" clId="{79AD01B1-C200-4FAB-8E05-6A4BF7F578BF}" dt="2026-05-12T07:55:47.317" v="618" actId="207"/>
           <ac:spMkLst>
             <pc:docMk/>
             <pc:sldMk cId="0" sldId="262"/>
@@ -673,7 +507,7 @@
           </ac:spMkLst>
         </pc:spChg>
         <pc:spChg chg="del mod">
-          <ac:chgData name="Rashmi Bhat Kekanaje" userId="33b2e9ea-e347-4a93-907a-aa92300ac3d3" providerId="ADAL" clId="{79AD01B1-C200-4FAB-8E05-6A4BF7F578BF}" dt="2026-05-09T17:41:46.595" v="275" actId="255"/>
+          <ac:chgData name="Rashmi Bhat Kekanaje" userId="33b2e9ea-e347-4a93-907a-aa92300ac3d3" providerId="ADAL" clId="{79AD01B1-C200-4FAB-8E05-6A4BF7F578BF}" dt="2026-05-12T07:56:17.281" v="621" actId="1076"/>
           <ac:spMkLst>
             <pc:docMk/>
             <pc:sldMk cId="0" sldId="262"/>
@@ -681,7 +515,7 @@
           </ac:spMkLst>
         </pc:spChg>
         <pc:spChg chg="del mod">
-          <ac:chgData name="Rashmi Bhat Kekanaje" userId="33b2e9ea-e347-4a93-907a-aa92300ac3d3" providerId="ADAL" clId="{79AD01B1-C200-4FAB-8E05-6A4BF7F578BF}" dt="2026-05-09T17:41:52.830" v="276" actId="255"/>
+          <ac:chgData name="Rashmi Bhat Kekanaje" userId="33b2e9ea-e347-4a93-907a-aa92300ac3d3" providerId="ADAL" clId="{79AD01B1-C200-4FAB-8E05-6A4BF7F578BF}" dt="2026-05-12T07:56:14.171" v="620" actId="1076"/>
           <ac:spMkLst>
             <pc:docMk/>
             <pc:sldMk cId="0" sldId="262"/>
@@ -689,7 +523,7 @@
           </ac:spMkLst>
         </pc:spChg>
         <pc:spChg chg="del mod">
-          <ac:chgData name="Rashmi Bhat Kekanaje" userId="33b2e9ea-e347-4a93-907a-aa92300ac3d3" providerId="ADAL" clId="{79AD01B1-C200-4FAB-8E05-6A4BF7F578BF}" dt="2026-05-10T08:29:59.580" v="290" actId="20577"/>
+          <ac:chgData name="Rashmi Bhat Kekanaje" userId="33b2e9ea-e347-4a93-907a-aa92300ac3d3" providerId="ADAL" clId="{79AD01B1-C200-4FAB-8E05-6A4BF7F578BF}" dt="2026-05-12T07:10:40.640" v="603" actId="14100"/>
           <ac:spMkLst>
             <pc:docMk/>
             <pc:sldMk cId="0" sldId="262"/>
@@ -697,7 +531,7 @@
           </ac:spMkLst>
         </pc:spChg>
         <pc:spChg chg="del mod">
-          <ac:chgData name="Rashmi Bhat Kekanaje" userId="33b2e9ea-e347-4a93-907a-aa92300ac3d3" providerId="ADAL" clId="{79AD01B1-C200-4FAB-8E05-6A4BF7F578BF}" dt="2026-05-09T17:42:17.157" v="282" actId="20577"/>
+          <ac:chgData name="Rashmi Bhat Kekanaje" userId="33b2e9ea-e347-4a93-907a-aa92300ac3d3" providerId="ADAL" clId="{79AD01B1-C200-4FAB-8E05-6A4BF7F578BF}" dt="2026-05-12T07:09:56.907" v="602" actId="1076"/>
           <ac:spMkLst>
             <pc:docMk/>
             <pc:sldMk cId="0" sldId="262"/>
@@ -711,22 +545,6 @@
           <pc:docMk/>
           <pc:sldMasterMk cId="2209977519" sldId="2147483648"/>
         </pc:sldMasterMkLst>
-        <pc:spChg chg="add del">
-          <ac:chgData name="Rashmi Bhat Kekanaje" userId="33b2e9ea-e347-4a93-907a-aa92300ac3d3" providerId="ADAL" clId="{79AD01B1-C200-4FAB-8E05-6A4BF7F578BF}" dt="2026-05-09T16:54:46.046" v="13" actId="33475"/>
-          <ac:spMkLst>
-            <pc:docMk/>
-            <pc:sldMasterMk cId="2209977519" sldId="2147483648"/>
-            <ac:spMk id="9" creationId="{1DFC842F-8CA8-54AF-5F71-2BAF54CD2024}"/>
-          </ac:spMkLst>
-        </pc:spChg>
-        <pc:spChg chg="add del">
-          <ac:chgData name="Rashmi Bhat Kekanaje" userId="33b2e9ea-e347-4a93-907a-aa92300ac3d3" providerId="ADAL" clId="{79AD01B1-C200-4FAB-8E05-6A4BF7F578BF}" dt="2026-05-09T16:54:46.046" v="13" actId="33475"/>
-          <ac:spMkLst>
-            <pc:docMk/>
-            <pc:sldMasterMk cId="2209977519" sldId="2147483648"/>
-            <ac:spMk id="10" creationId="{82201481-32A1-25BD-54CE-5039FEC36B57}"/>
-          </ac:spMkLst>
-        </pc:spChg>
       </pc:sldMasterChg>
     </pc:docChg>
   </pc:docChgLst>
@@ -912,7 +730,7 @@
           <a:p>
             <a:fld id="{5BCAD085-E8A6-8845-BD4E-CB4CCA059FC4}" type="datetimeFigureOut">
               <a:rPr lang="en-US" smtClean="0"/>
-              <a:t>5/10/2026</a:t>
+              <a:t>5/12/2026</a:t>
             </a:fld>
             <a:endParaRPr lang="en-US"/>
           </a:p>
@@ -1080,7 +898,7 @@
           <a:p>
             <a:fld id="{5BCAD085-E8A6-8845-BD4E-CB4CCA059FC4}" type="datetimeFigureOut">
               <a:rPr lang="en-US" smtClean="0"/>
-              <a:t>5/10/2026</a:t>
+              <a:t>5/12/2026</a:t>
             </a:fld>
             <a:endParaRPr lang="en-US"/>
           </a:p>
@@ -1258,7 +1076,7 @@
           <a:p>
             <a:fld id="{5BCAD085-E8A6-8845-BD4E-CB4CCA059FC4}" type="datetimeFigureOut">
               <a:rPr lang="en-US" smtClean="0"/>
-              <a:t>5/10/2026</a:t>
+              <a:t>5/12/2026</a:t>
             </a:fld>
             <a:endParaRPr lang="en-US"/>
           </a:p>
@@ -1426,7 +1244,7 @@
           <a:p>
             <a:fld id="{5BCAD085-E8A6-8845-BD4E-CB4CCA059FC4}" type="datetimeFigureOut">
               <a:rPr lang="en-US" smtClean="0"/>
-              <a:t>5/10/2026</a:t>
+              <a:t>5/12/2026</a:t>
             </a:fld>
             <a:endParaRPr lang="en-US"/>
           </a:p>
@@ -1671,7 +1489,7 @@
           <a:p>
             <a:fld id="{5BCAD085-E8A6-8845-BD4E-CB4CCA059FC4}" type="datetimeFigureOut">
               <a:rPr lang="en-US" smtClean="0"/>
-              <a:t>5/10/2026</a:t>
+              <a:t>5/12/2026</a:t>
             </a:fld>
             <a:endParaRPr lang="en-US"/>
           </a:p>
@@ -1956,7 +1774,7 @@
           <a:p>
             <a:fld id="{5BCAD085-E8A6-8845-BD4E-CB4CCA059FC4}" type="datetimeFigureOut">
               <a:rPr lang="en-US" smtClean="0"/>
-              <a:t>5/10/2026</a:t>
+              <a:t>5/12/2026</a:t>
             </a:fld>
             <a:endParaRPr lang="en-US"/>
           </a:p>
@@ -2375,7 +2193,7 @@
           <a:p>
             <a:fld id="{5BCAD085-E8A6-8845-BD4E-CB4CCA059FC4}" type="datetimeFigureOut">
               <a:rPr lang="en-US" smtClean="0"/>
-              <a:t>5/10/2026</a:t>
+              <a:t>5/12/2026</a:t>
             </a:fld>
             <a:endParaRPr lang="en-US"/>
           </a:p>
@@ -2492,7 +2310,7 @@
           <a:p>
             <a:fld id="{5BCAD085-E8A6-8845-BD4E-CB4CCA059FC4}" type="datetimeFigureOut">
               <a:rPr lang="en-US" smtClean="0"/>
-              <a:t>5/10/2026</a:t>
+              <a:t>5/12/2026</a:t>
             </a:fld>
             <a:endParaRPr lang="en-US"/>
           </a:p>
@@ -2587,7 +2405,7 @@
           <a:p>
             <a:fld id="{5BCAD085-E8A6-8845-BD4E-CB4CCA059FC4}" type="datetimeFigureOut">
               <a:rPr lang="en-US" smtClean="0"/>
-              <a:t>5/10/2026</a:t>
+              <a:t>5/12/2026</a:t>
             </a:fld>
             <a:endParaRPr lang="en-US"/>
           </a:p>
@@ -2862,7 +2680,7 @@
           <a:p>
             <a:fld id="{5BCAD085-E8A6-8845-BD4E-CB4CCA059FC4}" type="datetimeFigureOut">
               <a:rPr lang="en-US" smtClean="0"/>
-              <a:t>5/10/2026</a:t>
+              <a:t>5/12/2026</a:t>
             </a:fld>
             <a:endParaRPr lang="en-US"/>
           </a:p>
@@ -3114,7 +2932,7 @@
           <a:p>
             <a:fld id="{5BCAD085-E8A6-8845-BD4E-CB4CCA059FC4}" type="datetimeFigureOut">
               <a:rPr lang="en-US" smtClean="0"/>
-              <a:t>5/10/2026</a:t>
+              <a:t>5/12/2026</a:t>
             </a:fld>
             <a:endParaRPr lang="en-US"/>
           </a:p>
@@ -3325,7 +3143,7 @@
           <a:p>
             <a:fld id="{5BCAD085-E8A6-8845-BD4E-CB4CCA059FC4}" type="datetimeFigureOut">
               <a:rPr lang="en-US" smtClean="0"/>
-              <a:t>5/10/2026</a:t>
+              <a:t>5/12/2026</a:t>
             </a:fld>
             <a:endParaRPr lang="en-US"/>
           </a:p>
@@ -3782,7 +3600,7 @@
         <p:spPr>
           <a:xfrm>
             <a:off x="274320" y="731520"/>
-            <a:ext cx="4114800" cy="1359346"/>
+            <a:ext cx="4114800" cy="1513235"/>
           </a:xfrm>
           <a:prstGeom prst="rect">
             <a:avLst/>
@@ -3848,7 +3666,7 @@
             </a:pPr>
             <a:r>
               <a:rPr sz="1000" dirty="0"/>
-              <a:t>• Product mix complexity: shifting bottlenecks</a:t>
+              <a:t>• Product mix complexity: different UPH rates (2 hrs/unit vs 1.5 hrs/unit), shared bottleneck capacity</a:t>
             </a:r>
           </a:p>
           <a:p>
@@ -3886,7 +3704,7 @@
         <p:spPr>
           <a:xfrm>
             <a:off x="4663440" y="731520"/>
-            <a:ext cx="4206240" cy="1500411"/>
+            <a:ext cx="4206240" cy="1808187"/>
           </a:xfrm>
           <a:prstGeom prst="rect">
             <a:avLst/>
@@ -3940,7 +3758,7 @@
             </a:pPr>
             <a:r>
               <a:rPr sz="1000" dirty="0"/>
-              <a:t>2. Risk Detection: OTIF gap × WIP × capacity</a:t>
+              <a:t>2. Risk Detection: ML + NumPy, 5 factors (OTIF gap, WIP, capacity, product mix, cross-week risk), &lt;100ms</a:t>
             </a:r>
           </a:p>
           <a:p>
@@ -3954,6 +3772,11 @@
               <a:rPr sz="1000" dirty="0"/>
               <a:t>3. Cause Classifier: LLM+RAG: 6 categories</a:t>
             </a:r>
+            <a:r>
+              <a:rPr lang="en-US" sz="1000" dirty="0"/>
+              <a:t> (Downtime, UPH degradation, WIP queue, Material shortages, Quality, Other)</a:t>
+            </a:r>
+            <a:endParaRPr sz="1000" dirty="0"/>
           </a:p>
           <a:p>
             <a:pPr>
@@ -4135,6 +3958,7 @@
               </a:defRPr>
             </a:pPr>
             <a:r>
+              <a:rPr dirty="0"/>
               <a:t>CLASSIFY</a:t>
             </a:r>
           </a:p>
@@ -4363,7 +4187,7 @@
               <a:defRPr sz="900"/>
             </a:pPr>
             <a:r>
-              <a:rPr sz="1000" dirty="0"/>
+              <a:rPr lang="en-US" sz="1000" dirty="0"/>
               <a:t>• Kafka down: PostgreSQL CDC (30-sec lag) + DEGRADED MODE banner</a:t>
             </a:r>
           </a:p>
@@ -4375,7 +4199,7 @@
               <a:defRPr sz="900"/>
             </a:pPr>
             <a:r>
-              <a:rPr sz="1000" dirty="0"/>
+              <a:rPr lang="en-US" sz="1000" dirty="0"/>
               <a:t>• LLM timeout: 3 retries → escalate to human classification</a:t>
             </a:r>
           </a:p>
@@ -4750,7 +4574,7 @@
               </a:defRPr>
             </a:pPr>
             <a:r>
-              <a:rPr sz="1000"/>
+              <a:rPr sz="1000" dirty="0"/>
               <a:t>Kafka | CDC | Vector DB | TimescaleDB</a:t>
             </a:r>
           </a:p>
@@ -5076,7 +4900,7 @@
         </p:nvSpPr>
         <p:spPr>
           <a:xfrm>
-            <a:off x="6949440" y="731520"/>
+            <a:off x="6978994" y="583566"/>
             <a:ext cx="1920240" cy="1469633"/>
           </a:xfrm>
           <a:prstGeom prst="rect">
@@ -5170,7 +4994,7 @@
         </p:nvSpPr>
         <p:spPr>
           <a:xfrm>
-            <a:off x="274320" y="2105784"/>
+            <a:off x="274320" y="2271537"/>
             <a:ext cx="1650645" cy="276999"/>
           </a:xfrm>
           <a:prstGeom prst="rect">
@@ -5207,14 +5031,14 @@
           <p:nvPr>
             <p:extLst>
               <p:ext uri="{D42A27DB-BD31-4B8C-83A1-F6EECF244321}">
-                <p14:modId xmlns:p14="http://schemas.microsoft.com/office/powerpoint/2010/main" val="1689353407"/>
+                <p14:modId xmlns:p14="http://schemas.microsoft.com/office/powerpoint/2010/main" val="2367424504"/>
               </p:ext>
             </p:extLst>
           </p:nvPr>
         </p:nvGraphicFramePr>
         <p:xfrm>
-          <a:off x="274320" y="2428683"/>
-          <a:ext cx="8595360" cy="1749450"/>
+          <a:off x="274320" y="2745198"/>
+          <a:ext cx="8595360" cy="2063445"/>
         </p:xfrm>
         <a:graphic>
           <a:graphicData uri="http://schemas.openxmlformats.org/drawingml/2006/table">
@@ -5230,14 +5054,14 @@
                     </a:ext>
                   </a:extLst>
                 </a:gridCol>
-                <a:gridCol w="5029200">
+                <a:gridCol w="4503089">
                   <a:extLst>
                     <a:ext uri="{9D8B030D-6E8A-4147-A177-3AD203B41FA5}">
                       <a16:colId xmlns:a16="http://schemas.microsoft.com/office/drawing/2014/main" val="20001"/>
                     </a:ext>
                   </a:extLst>
                 </a:gridCol>
-                <a:gridCol w="1737360">
+                <a:gridCol w="2263471">
                   <a:extLst>
                     <a:ext uri="{9D8B030D-6E8A-4147-A177-3AD203B41FA5}">
                       <a16:colId xmlns:a16="http://schemas.microsoft.com/office/drawing/2014/main" val="20002"/>
@@ -5334,9 +5158,22 @@
                         <a:defRPr sz="700" b="1"/>
                       </a:pPr>
                       <a:r>
-                        <a:rPr sz="1000"/>
+                        <a:rPr sz="1000" dirty="0" err="1"/>
                         <a:t>wip_snapshot</a:t>
                       </a:r>
+                      <a:r>
+                        <a:rPr lang="en-US" sz="1000" dirty="0"/>
+                        <a:t> (current </a:t>
+                      </a:r>
+                      <a:r>
+                        <a:rPr lang="en-US" sz="1000" dirty="0" err="1"/>
+                        <a:t>wip</a:t>
+                      </a:r>
+                      <a:r>
+                        <a:rPr lang="en-US" sz="1000" dirty="0"/>
+                        <a:t> snapshot)</a:t>
+                      </a:r>
+                      <a:endParaRPr sz="1000" dirty="0"/>
                     </a:p>
                   </a:txBody>
                   <a:tcPr anchor="ctr"/>
@@ -5366,7 +5203,7 @@
                         <a:defRPr sz="700"/>
                       </a:pPr>
                       <a:r>
-                        <a:rPr sz="1000"/>
+                        <a:rPr sz="1000" dirty="0"/>
                         <a:t>Hourly (W1/W2) / 3hrs (W3/W4)</a:t>
                       </a:r>
                     </a:p>
@@ -5389,9 +5226,14 @@
                         <a:defRPr sz="700" b="1"/>
                       </a:pPr>
                       <a:r>
-                        <a:rPr sz="1000"/>
+                        <a:rPr sz="1000" dirty="0" err="1"/>
                         <a:t>route_master</a:t>
                       </a:r>
+                      <a:r>
+                        <a:rPr lang="en-US" sz="1000" dirty="0"/>
+                        <a:t> (process flow)</a:t>
+                      </a:r>
+                      <a:endParaRPr sz="1000" dirty="0"/>
                     </a:p>
                   </a:txBody>
                   <a:tcPr anchor="ctr"/>
@@ -5444,9 +5286,14 @@
                         <a:defRPr sz="700" b="1"/>
                       </a:pPr>
                       <a:r>
-                        <a:rPr sz="1000"/>
+                        <a:rPr sz="1000" dirty="0" err="1"/>
                         <a:t>tool_status</a:t>
                       </a:r>
+                      <a:r>
+                        <a:rPr lang="en-US" sz="1000" dirty="0"/>
+                        <a:t> (tracks equipment)</a:t>
+                      </a:r>
+                      <a:endParaRPr sz="1000" dirty="0"/>
                     </a:p>
                   </a:txBody>
                   <a:tcPr anchor="ctr"/>
@@ -5460,9 +5307,34 @@
                         <a:defRPr sz="700"/>
                       </a:pPr>
                       <a:r>
-                        <a:rPr sz="1000"/>
-                        <a:t>tool_id, tool_group, status, eta_recovery, owner_id</a:t>
+                        <a:rPr sz="1000" dirty="0" err="1"/>
+                        <a:t>tool_id</a:t>
                       </a:r>
+                      <a:r>
+                        <a:rPr sz="1000" dirty="0"/>
+                        <a:t>, </a:t>
+                      </a:r>
+                      <a:r>
+                        <a:rPr sz="1000" dirty="0" err="1"/>
+                        <a:t>tool_group</a:t>
+                      </a:r>
+                      <a:r>
+                        <a:rPr sz="1000" dirty="0"/>
+                        <a:t>, status, </a:t>
+                      </a:r>
+                      <a:r>
+                        <a:rPr sz="1000" dirty="0" err="1"/>
+                        <a:t>eta_recovery</a:t>
+                      </a:r>
+                      <a:r>
+                        <a:rPr sz="1000" dirty="0"/>
+                        <a:t>, </a:t>
+                      </a:r>
+                      <a:r>
+                        <a:rPr sz="1000" dirty="0" err="1"/>
+                        <a:t>owner_id</a:t>
+                      </a:r>
+                      <a:endParaRPr sz="1000" dirty="0"/>
                     </a:p>
                   </a:txBody>
                   <a:tcPr anchor="ctr"/>
@@ -5499,9 +5371,14 @@
                         <a:defRPr sz="700" b="1"/>
                       </a:pPr>
                       <a:r>
-                        <a:rPr sz="1000"/>
+                        <a:rPr sz="1000" dirty="0" err="1"/>
                         <a:t>oee_hourly</a:t>
                       </a:r>
+                      <a:r>
+                        <a:rPr lang="en-US" sz="1000" dirty="0"/>
+                        <a:t> (equipment performance)</a:t>
+                      </a:r>
+                      <a:endParaRPr sz="1000" dirty="0"/>
                     </a:p>
                   </a:txBody>
                   <a:tcPr anchor="ctr"/>
@@ -5515,9 +5392,26 @@
                         <a:defRPr sz="700"/>
                       </a:pPr>
                       <a:r>
-                        <a:rPr sz="1000"/>
-                        <a:t>tool_group, availability, performance, quality, oee, uph_actual</a:t>
+                        <a:rPr sz="1000" dirty="0" err="1"/>
+                        <a:t>tool_group</a:t>
                       </a:r>
+                      <a:r>
+                        <a:rPr sz="1000" dirty="0"/>
+                        <a:t>, availability, performance, quality, </a:t>
+                      </a:r>
+                      <a:r>
+                        <a:rPr sz="1000" dirty="0" err="1"/>
+                        <a:t>oee</a:t>
+                      </a:r>
+                      <a:r>
+                        <a:rPr sz="1000" dirty="0"/>
+                        <a:t>, </a:t>
+                      </a:r>
+                      <a:r>
+                        <a:rPr sz="1000" dirty="0" err="1"/>
+                        <a:t>uph_actual</a:t>
+                      </a:r>
+                      <a:endParaRPr sz="1000" dirty="0"/>
                     </a:p>
                   </a:txBody>
                   <a:tcPr anchor="ctr"/>
@@ -5554,9 +5448,14 @@
                         <a:defRPr sz="700" b="1"/>
                       </a:pPr>
                       <a:r>
-                        <a:rPr sz="1000"/>
+                        <a:rPr sz="1000" dirty="0" err="1"/>
                         <a:t>capacity_vs_demand</a:t>
                       </a:r>
+                      <a:r>
+                        <a:rPr lang="en-US" sz="1000" dirty="0"/>
+                        <a:t> (summary)</a:t>
+                      </a:r>
+                      <a:endParaRPr sz="1000" dirty="0"/>
                     </a:p>
                   </a:txBody>
                   <a:tcPr anchor="ctr"/>
@@ -5644,8 +5543,8 @@
         </p:nvSpPr>
         <p:spPr>
           <a:xfrm>
-            <a:off x="274320" y="4757551"/>
-            <a:ext cx="4114800" cy="828432"/>
+            <a:off x="274320" y="5125158"/>
+            <a:ext cx="4178410" cy="1007968"/>
           </a:xfrm>
           <a:prstGeom prst="rect">
             <a:avLst/>
@@ -5675,7 +5574,15 @@
             </a:pPr>
             <a:r>
               <a:rPr sz="1200" dirty="0"/>
-              <a:t>DATA QUALITY CHECKS (Great Expectations)</a:t>
+              <a:t>DATA QUALITY CHECKS (Great Expectations</a:t>
+            </a:r>
+            <a:r>
+              <a:rPr lang="en-US" sz="1200" dirty="0"/>
+              <a:t>- Unit tests for data</a:t>
+            </a:r>
+            <a:r>
+              <a:rPr sz="1200" dirty="0"/>
+              <a:t>)</a:t>
             </a:r>
           </a:p>
           <a:p>
@@ -5687,15 +5594,15 @@
             </a:pPr>
             <a:r>
               <a:rPr sz="1000" dirty="0"/>
-              <a:t>• Freshness: MES lag &lt;10 min (W1), &lt;2 </a:t>
-            </a:r>
-            <a:r>
-              <a:rPr sz="1000" dirty="0" err="1"/>
-              <a:t>hrs</a:t>
+              <a:t>• Freshness: MES lag &lt;</a:t>
+            </a:r>
+            <a:r>
+              <a:rPr lang="en-US" sz="1000" dirty="0"/>
+              <a:t>3</a:t>
             </a:r>
             <a:r>
               <a:rPr sz="1000" dirty="0"/>
-              <a:t> (W2–W4)</a:t>
+              <a:t>0 min (W1), &lt;2 hrs (W2–W4)</a:t>
             </a:r>
           </a:p>
           <a:p>
@@ -5732,8 +5639,26 @@
             </a:pPr>
             <a:r>
               <a:rPr sz="1000" dirty="0"/>
-              <a:t>• Sanity: UPH ≤2× baseline, queue &lt;7 days, OEE ≤100%</a:t>
-            </a:r>
+              <a:t>• Sanity: UPH ≤2× baseline, queue &lt;7 days, OEE </a:t>
+            </a:r>
+            <a:r>
+              <a:rPr lang="en-US" sz="1000" dirty="0"/>
+              <a:t>&gt;</a:t>
+            </a:r>
+            <a:r>
+              <a:rPr sz="1000" dirty="0"/>
+              <a:t>100%</a:t>
+            </a:r>
+            <a:endParaRPr lang="en-US" sz="1000" dirty="0"/>
+          </a:p>
+          <a:p>
+            <a:pPr>
+              <a:spcAft>
+                <a:spcPts val="200"/>
+              </a:spcAft>
+              <a:defRPr sz="800"/>
+            </a:pPr>
+            <a:endParaRPr sz="1000" dirty="0"/>
           </a:p>
         </p:txBody>
       </p:sp>
@@ -5745,7 +5670,7 @@
         </p:nvSpPr>
         <p:spPr>
           <a:xfrm>
-            <a:off x="4572000" y="4616487"/>
+            <a:off x="4572000" y="5125158"/>
             <a:ext cx="4297680" cy="969496"/>
           </a:xfrm>
           <a:prstGeom prst="rect">
@@ -6022,6 +5947,7 @@
               </a:defRPr>
             </a:pPr>
             <a:r>
+              <a:rPr dirty="0"/>
               <a:t>LangGraph | LangChain | ReAct | OR-Tools</a:t>
             </a:r>
           </a:p>
@@ -6036,7 +5962,7 @@
         <p:spPr>
           <a:xfrm>
             <a:off x="274320" y="731520"/>
-            <a:ext cx="8595360" cy="610424"/>
+            <a:ext cx="8595360" cy="1225977"/>
           </a:xfrm>
           <a:prstGeom prst="rect">
             <a:avLst/>
@@ -6075,31 +6001,52 @@
             </a:pPr>
             <a:r>
               <a:rPr lang="en-US" sz="1000" dirty="0"/>
-              <a:t>• </a:t>
-            </a:r>
-            <a:r>
-              <a:rPr lang="en-US" sz="1000" dirty="0" err="1"/>
-              <a:t>LangGraph</a:t>
-            </a:r>
+              <a:t>• LangGraph → State-machine orchestration  </a:t>
+            </a:r>
+          </a:p>
+          <a:p>
+            <a:pPr>
+              <a:defRPr sz="800"/>
+            </a:pPr>
             <a:r>
               <a:rPr lang="en-US" sz="1000" dirty="0"/>
-              <a:t> → State-machine orchestration  • </a:t>
-            </a:r>
-            <a:r>
-              <a:rPr lang="en-US" sz="1000" dirty="0" err="1"/>
-              <a:t>LangChain</a:t>
-            </a:r>
+              <a:t>• LangChain → Tool binding, LLM routing  </a:t>
+            </a:r>
+          </a:p>
+          <a:p>
+            <a:pPr>
+              <a:defRPr sz="800"/>
+            </a:pPr>
             <a:r>
               <a:rPr lang="en-US" sz="1000" dirty="0"/>
-              <a:t> → Tool binding, LLM routing  • LLM → Reasoning, classification  • Vector DB </a:t>
-            </a:r>
-            <a:r>
-              <a:rPr lang="en-US" sz="1000"/>
-              <a:t>→ for </a:t>
-            </a:r>
+              <a:t>• Primary and secondary LLMs → Reasoning, classification  </a:t>
+            </a:r>
+          </a:p>
+          <a:p>
+            <a:pPr>
+              <a:defRPr sz="800"/>
+            </a:pPr>
             <a:r>
               <a:rPr lang="en-US" sz="1000" dirty="0"/>
-              <a:t>RAG  • Kafka → Event streaming, CDC  • PostgreSQL → Structured + time-series</a:t>
+              <a:t>• Vector DB → for RAG  </a:t>
+            </a:r>
+          </a:p>
+          <a:p>
+            <a:pPr>
+              <a:defRPr sz="800"/>
+            </a:pPr>
+            <a:r>
+              <a:rPr lang="en-US" sz="1000" dirty="0"/>
+              <a:t>• Managed Kafka → Event streaming, CDC  </a:t>
+            </a:r>
+          </a:p>
+          <a:p>
+            <a:pPr>
+              <a:defRPr sz="800"/>
+            </a:pPr>
+            <a:r>
+              <a:rPr lang="en-US" sz="1000" dirty="0"/>
+              <a:t>• PostgreSQL → Structured + time-series</a:t>
             </a:r>
           </a:p>
         </p:txBody>
@@ -6112,7 +6059,7 @@
         </p:nvSpPr>
         <p:spPr>
           <a:xfrm>
-            <a:off x="274320" y="1463040"/>
+            <a:off x="274321" y="2071246"/>
             <a:ext cx="4206240" cy="2654573"/>
           </a:xfrm>
           <a:prstGeom prst="rect">
@@ -6367,8 +6314,8 @@
         </p:nvSpPr>
         <p:spPr>
           <a:xfrm>
-            <a:off x="4663440" y="1463040"/>
-            <a:ext cx="4206240" cy="1495281"/>
+            <a:off x="4663440" y="2071246"/>
+            <a:ext cx="4206240" cy="1803058"/>
           </a:xfrm>
           <a:prstGeom prst="rect">
             <a:avLst/>
@@ -6410,23 +6357,43 @@
             </a:pPr>
             <a:r>
               <a:rPr lang="en-US" sz="1000" dirty="0"/>
-              <a:t>• Data Quality → </a:t>
-            </a:r>
-            <a:r>
-              <a:rPr lang="en-US" sz="1000" dirty="0" err="1"/>
-              <a:t>LangChain</a:t>
-            </a:r>
+              <a:t>• Data Quality → LangChain DataLoader + Great Expectations</a:t>
+            </a:r>
+          </a:p>
+          <a:p>
+            <a:pPr>
+              <a:spcAft>
+                <a:spcPts val="400"/>
+              </a:spcAft>
+              <a:defRPr sz="800"/>
+            </a:pPr>
+            <a:r>
+              <a:rPr sz="1000" dirty="0"/>
+              <a:t>• Risk Detection → ML (Random Forest) + NumPy scoring: 5 factors (OTIF gap, WIP, capacity, product mix with UPH-weighting, cross-week impact)</a:t>
+            </a:r>
+          </a:p>
+          <a:p>
+            <a:pPr>
+              <a:spcAft>
+                <a:spcPts val="400"/>
+              </a:spcAft>
+              <a:defRPr sz="800"/>
+            </a:pPr>
             <a:r>
               <a:rPr lang="en-US" sz="1000" dirty="0"/>
-              <a:t> </a:t>
-            </a:r>
-            <a:r>
-              <a:rPr lang="en-US" sz="1000" dirty="0" err="1"/>
-              <a:t>DataLoader</a:t>
-            </a:r>
+              <a:t>• Cause Classifier → LLMChain + Pydantic | RAG: top-5 incidents</a:t>
+            </a:r>
+          </a:p>
+          <a:p>
+            <a:pPr>
+              <a:spcAft>
+                <a:spcPts val="400"/>
+              </a:spcAft>
+              <a:defRPr sz="800"/>
+            </a:pPr>
             <a:r>
               <a:rPr lang="en-US" sz="1000" dirty="0"/>
-              <a:t> + Great Expectations</a:t>
+              <a:t>• Follow-Up → ReAct Agent | Tools: Slack, email, CMMS</a:t>
             </a:r>
           </a:p>
           <a:p>
@@ -6437,96 +6404,20 @@
               <a:defRPr sz="800"/>
             </a:pPr>
             <a:r>
+              <a:rPr sz="1000" dirty="0"/>
+              <a:t>• Trade-Off → OR-Tools SCIP | Capacity allocation per product per week with cross-week buffers</a:t>
+            </a:r>
+          </a:p>
+          <a:p>
+            <a:pPr>
+              <a:spcAft>
+                <a:spcPts val="400"/>
+              </a:spcAft>
+              <a:defRPr sz="800"/>
+            </a:pPr>
+            <a:r>
               <a:rPr lang="en-US" sz="1000" dirty="0"/>
-              <a:t>• Risk Detection → Custom Python scoring (NOT LLM—latency)</a:t>
-            </a:r>
-          </a:p>
-          <a:p>
-            <a:pPr>
-              <a:spcAft>
-                <a:spcPts val="400"/>
-              </a:spcAft>
-              <a:defRPr sz="800"/>
-            </a:pPr>
-            <a:r>
-              <a:rPr lang="en-US" sz="1000" dirty="0"/>
-              <a:t>• Cause Classifier → </a:t>
-            </a:r>
-            <a:r>
-              <a:rPr lang="en-US" sz="1000" dirty="0" err="1"/>
-              <a:t>LLMChain</a:t>
-            </a:r>
-            <a:r>
-              <a:rPr lang="en-US" sz="1000" dirty="0"/>
-              <a:t> + </a:t>
-            </a:r>
-            <a:r>
-              <a:rPr lang="en-US" sz="1000" dirty="0" err="1"/>
-              <a:t>Pydantic</a:t>
-            </a:r>
-            <a:r>
-              <a:rPr lang="en-US" sz="1000" dirty="0"/>
-              <a:t> | RAG: top-5 incidents</a:t>
-            </a:r>
-          </a:p>
-          <a:p>
-            <a:pPr>
-              <a:spcAft>
-                <a:spcPts val="400"/>
-              </a:spcAft>
-              <a:defRPr sz="800"/>
-            </a:pPr>
-            <a:r>
-              <a:rPr lang="en-US" sz="1000" dirty="0"/>
-              <a:t>• Follow-Up → </a:t>
-            </a:r>
-            <a:r>
-              <a:rPr lang="en-US" sz="1000" dirty="0" err="1"/>
-              <a:t>ReAct</a:t>
-            </a:r>
-            <a:r>
-              <a:rPr lang="en-US" sz="1000" dirty="0"/>
-              <a:t> Agent | Tools: Slack, email, CMMS</a:t>
-            </a:r>
-          </a:p>
-          <a:p>
-            <a:pPr>
-              <a:spcAft>
-                <a:spcPts val="400"/>
-              </a:spcAft>
-              <a:defRPr sz="800"/>
-            </a:pPr>
-            <a:r>
-              <a:rPr lang="en-US" sz="1000" dirty="0"/>
-              <a:t>• Trade-Off → OR-Tools / </a:t>
-            </a:r>
-            <a:r>
-              <a:rPr lang="en-US" sz="1000" dirty="0" err="1"/>
-              <a:t>PuLP</a:t>
-            </a:r>
-            <a:r>
-              <a:rPr lang="en-US" sz="1000" dirty="0"/>
-              <a:t> | What-if capacity reallocation</a:t>
-            </a:r>
-          </a:p>
-          <a:p>
-            <a:pPr>
-              <a:spcAft>
-                <a:spcPts val="400"/>
-              </a:spcAft>
-              <a:defRPr sz="800"/>
-            </a:pPr>
-            <a:r>
-              <a:rPr lang="en-US" sz="1000" dirty="0"/>
-              <a:t>• Action &amp; Audit → </a:t>
-            </a:r>
-            <a:r>
-              <a:rPr lang="en-US" sz="1000" dirty="0" err="1"/>
-              <a:t>ToolExecutor</a:t>
-            </a:r>
-            <a:r>
-              <a:rPr lang="en-US" sz="1000" dirty="0"/>
-              <a:t> | Hash-chained audit log</a:t>
+              <a:t>• Action &amp; Audit → ToolExecutor | Hash-chained audit log</a:t>
             </a:r>
           </a:p>
         </p:txBody>
@@ -6539,7 +6430,7 @@
         </p:nvSpPr>
         <p:spPr>
           <a:xfrm>
-            <a:off x="274320" y="4238709"/>
+            <a:off x="274320" y="4807390"/>
             <a:ext cx="8595360" cy="1561966"/>
           </a:xfrm>
           <a:prstGeom prst="rect">
@@ -7133,7 +7024,7 @@
         <p:spPr>
           <a:xfrm>
             <a:off x="4754880" y="731519"/>
-            <a:ext cx="4203590" cy="1097736"/>
+            <a:ext cx="4203590" cy="1405513"/>
           </a:xfrm>
           <a:prstGeom prst="rect">
             <a:avLst/>
@@ -7187,7 +7078,7 @@
             </a:pPr>
             <a:r>
               <a:rPr sz="1000" dirty="0"/>
-              <a:t>• Mix Balance: balanced % per product</a:t>
+              <a:t>• Mix Balance: UPH-weighted capacity (Product A: 2 hrs/unit vs Product B: 1.5 hrs/unit)</a:t>
             </a:r>
           </a:p>
           <a:p>
@@ -7199,7 +7090,7 @@
             </a:pPr>
             <a:r>
               <a:rPr sz="1000" dirty="0"/>
-              <a:t>• Capacity Reservation: W2-W4 keep capacity buffer</a:t>
+              <a:t>• Capacity Reservation: W2-W4 keep buffer (e.g., 100 hrs of 500 hrs reserved for W2)</a:t>
             </a:r>
           </a:p>
           <a:p>
@@ -7224,7 +7115,7 @@
         </p:nvSpPr>
         <p:spPr>
           <a:xfrm>
-            <a:off x="4843670" y="2169681"/>
+            <a:off x="4843670" y="2220864"/>
             <a:ext cx="4114800" cy="1274708"/>
           </a:xfrm>
           <a:prstGeom prst="rect">
@@ -7300,15 +7191,7 @@
             </a:pPr>
             <a:r>
               <a:rPr sz="900" dirty="0"/>
-              <a:t>• </a:t>
-            </a:r>
-            <a:r>
-              <a:rPr sz="900" dirty="0" err="1"/>
-              <a:t>LangSmith</a:t>
-            </a:r>
-            <a:r>
-              <a:rPr sz="900" dirty="0"/>
-              <a:t> trace ID for observability</a:t>
+              <a:t>• LangSmith trace ID for observability</a:t>
             </a:r>
           </a:p>
           <a:p>
@@ -8480,7 +8363,7 @@
         </p:nvSpPr>
         <p:spPr>
           <a:xfrm>
-            <a:off x="274320" y="731520"/>
+            <a:off x="274320" y="663404"/>
             <a:ext cx="8595360" cy="228600"/>
           </a:xfrm>
           <a:prstGeom prst="rect">
@@ -8516,8 +8399,8 @@
         </p:nvSpPr>
         <p:spPr>
           <a:xfrm>
-            <a:off x="274320" y="1005840"/>
-            <a:ext cx="1715534" cy="774571"/>
+            <a:off x="279408" y="921076"/>
+            <a:ext cx="2920992" cy="774571"/>
           </a:xfrm>
           <a:prstGeom prst="rect">
             <a:avLst/>
@@ -8554,7 +8437,7 @@
             </a:pPr>
             <a:r>
               <a:rPr sz="1000" dirty="0"/>
-              <a:t>• OTIF improvement by week</a:t>
+              <a:t>• OTIF improvement by week AND by product family</a:t>
             </a:r>
           </a:p>
           <a:p>
@@ -8591,8 +8474,8 @@
         </p:nvSpPr>
         <p:spPr>
           <a:xfrm>
-            <a:off x="3200400" y="1005840"/>
-            <a:ext cx="1681871" cy="941283"/>
+            <a:off x="3200400" y="926467"/>
+            <a:ext cx="2574744" cy="1095172"/>
           </a:xfrm>
           <a:prstGeom prst="rect">
             <a:avLst/>
@@ -8629,13 +8512,8 @@
             </a:pPr>
             <a:r>
               <a:rPr sz="1000" dirty="0"/>
-              <a:t>• Detection lead &gt;48 </a:t>
-            </a:r>
-            <a:r>
-              <a:rPr sz="1000" dirty="0" err="1"/>
-              <a:t>hrs</a:t>
-            </a:r>
-            <a:endParaRPr sz="1000" dirty="0"/>
+              <a:t>• Detection lead &gt;48 hrs</a:t>
+            </a:r>
           </a:p>
           <a:p>
             <a:pPr>
@@ -8671,6 +8549,13 @@
             <a:r>
               <a:rPr sz="1000" dirty="0"/>
               <a:t>• OEE stability</a:t>
+            </a:r>
+            <a:br>
+              <a:rPr sz="1000" dirty="0"/>
+            </a:br>
+            <a:r>
+              <a:rPr sz="1000" dirty="0"/>
+              <a:t>• Bottleneck capacity balance across products</a:t>
             </a:r>
           </a:p>
         </p:txBody>
@@ -8683,8 +8568,8 @@
         </p:nvSpPr>
         <p:spPr>
           <a:xfrm>
-            <a:off x="6126480" y="1005840"/>
-            <a:ext cx="1571264" cy="774571"/>
+            <a:off x="6129343" y="921076"/>
+            <a:ext cx="1744388" cy="928459"/>
           </a:xfrm>
           <a:prstGeom prst="rect">
             <a:avLst/>
@@ -8721,15 +8606,7 @@
             </a:pPr>
             <a:r>
               <a:rPr sz="1000" dirty="0"/>
-              <a:t>• Closure time &lt;4 </a:t>
-            </a:r>
-            <a:r>
-              <a:rPr sz="1000" dirty="0" err="1"/>
-              <a:t>hrs</a:t>
-            </a:r>
-            <a:r>
-              <a:rPr sz="1000" dirty="0"/>
-              <a:t> (W1)</a:t>
+              <a:t>• Closure time &lt;4 hrs (W1)</a:t>
             </a:r>
           </a:p>
           <a:p>
@@ -8754,6 +8631,13 @@
             <a:r>
               <a:rPr sz="1000" dirty="0"/>
               <a:t>• Effort saved</a:t>
+            </a:r>
+            <a:br>
+              <a:rPr sz="1000" dirty="0"/>
+            </a:br>
+            <a:r>
+              <a:rPr sz="1000" dirty="0"/>
+              <a:t>• Cross-week impact accuracy</a:t>
             </a:r>
           </a:p>
         </p:txBody>
@@ -8766,7 +8650,7 @@
         </p:nvSpPr>
         <p:spPr>
           <a:xfrm>
-            <a:off x="274320" y="1783080"/>
+            <a:off x="266369" y="1895917"/>
             <a:ext cx="8595360" cy="228600"/>
           </a:xfrm>
           <a:prstGeom prst="rect">
@@ -8802,7 +8686,7 @@
         </p:nvSpPr>
         <p:spPr>
           <a:xfrm>
-            <a:off x="274320" y="2057400"/>
+            <a:off x="274320" y="2207873"/>
             <a:ext cx="2011680" cy="954107"/>
           </a:xfrm>
           <a:prstGeom prst="rect">
@@ -8877,12 +8761,8 @@
               </a:defRPr>
             </a:pPr>
             <a:r>
-              <a:rPr sz="1000" dirty="0" err="1"/>
-              <a:t>Internal monitoring</a:t>
-            </a:r>
-            <a:r>
               <a:rPr sz="1000" dirty="0"/>
-              <a:t> dashboard</a:t>
+              <a:t>Internal monitoring dashboard</a:t>
             </a:r>
           </a:p>
           <a:p>
@@ -8911,8 +8791,8 @@
         </p:nvSpPr>
         <p:spPr>
           <a:xfrm>
-            <a:off x="2468880" y="2057400"/>
-            <a:ext cx="2011680" cy="954107"/>
+            <a:off x="2468880" y="2203296"/>
+            <a:ext cx="2011680" cy="1100301"/>
           </a:xfrm>
           <a:prstGeom prst="rect">
             <a:avLst/>
@@ -8931,7 +8811,7 @@
               <a:spcAft>
                 <a:spcPts val="300"/>
               </a:spcAft>
-              <a:defRPr sz="900" b="1">
+              <a:defRPr sz="1400" b="1">
                 <a:solidFill>
                   <a:srgbClr val="FFFFFF"/>
                 </a:solidFill>
@@ -8939,71 +8819,57 @@
             </a:pPr>
             <a:r>
               <a:rPr sz="1100" dirty="0"/>
-              <a:t>WEEK 2: FOLLOW-UP</a:t>
-            </a:r>
-          </a:p>
-          <a:p>
-            <a:pPr algn="ctr">
-              <a:spcAft>
-                <a:spcPts val="100"/>
-              </a:spcAft>
-              <a:defRPr sz="700">
-                <a:solidFill>
-                  <a:srgbClr val="FFFFFF"/>
-                </a:solidFill>
-              </a:defRPr>
-            </a:pPr>
-            <a:r>
-              <a:rPr sz="1000" dirty="0"/>
-              <a:t>Follow-Up Agent (W1)</a:t>
-            </a:r>
-          </a:p>
-          <a:p>
-            <a:pPr algn="ctr">
-              <a:spcAft>
-                <a:spcPts val="100"/>
-              </a:spcAft>
-              <a:defRPr sz="700">
-                <a:solidFill>
-                  <a:srgbClr val="FFFFFF"/>
-                </a:solidFill>
-              </a:defRPr>
-            </a:pPr>
-            <a:r>
-              <a:rPr sz="1000" dirty="0"/>
-              <a:t>Slack/Teams + owner mapping</a:t>
-            </a:r>
-          </a:p>
-          <a:p>
-            <a:pPr algn="ctr">
-              <a:spcAft>
-                <a:spcPts val="100"/>
-              </a:spcAft>
-              <a:defRPr sz="700">
-                <a:solidFill>
-                  <a:srgbClr val="FFFFFF"/>
-                </a:solidFill>
-              </a:defRPr>
-            </a:pPr>
-            <a:r>
-              <a:rPr sz="1000" dirty="0"/>
-              <a:t>SLA tracking</a:t>
-            </a:r>
-          </a:p>
-          <a:p>
-            <a:pPr algn="ctr">
-              <a:spcAft>
-                <a:spcPts val="100"/>
-              </a:spcAft>
-              <a:defRPr sz="700">
-                <a:solidFill>
-                  <a:srgbClr val="FFFFFF"/>
-                </a:solidFill>
-              </a:defRPr>
-            </a:pPr>
-            <a:r>
-              <a:rPr sz="1000" dirty="0"/>
-              <a:t>GATE: Response high</a:t>
+              <a:t>WEEK 2: CLASSIFY</a:t>
+            </a:r>
+          </a:p>
+          <a:p>
+            <a:pPr>
+              <a:defRPr sz="1200"/>
+            </a:pPr>
+            <a:r>
+              <a:rPr sz="1000" dirty="0">
+                <a:solidFill>
+                  <a:schemeClr val="bg1"/>
+                </a:solidFill>
+              </a:rPr>
+              <a:t>Cause Classifier + RAG</a:t>
+            </a:r>
+          </a:p>
+          <a:p>
+            <a:pPr>
+              <a:defRPr sz="1100"/>
+            </a:pPr>
+            <a:r>
+              <a:rPr sz="1000" dirty="0">
+                <a:solidFill>
+                  <a:schemeClr val="bg1"/>
+                </a:solidFill>
+              </a:rPr>
+              <a:t>Classify root cause (DOWNTIME, WIP_QUEUE, etc.)Advisory mode only</a:t>
+            </a:r>
+            <a:r>
+              <a:rPr lang="en-US" sz="1000" dirty="0">
+                <a:solidFill>
+                  <a:schemeClr val="bg1"/>
+                </a:solidFill>
+              </a:rPr>
+              <a:t> </a:t>
+            </a:r>
+            <a:r>
+              <a:rPr sz="1000" b="1" dirty="0">
+                <a:solidFill>
+                  <a:schemeClr val="bg1"/>
+                </a:solidFill>
+              </a:rPr>
+              <a:t>GATE: Classification </a:t>
+            </a:r>
+            <a:r>
+              <a:rPr b="1" dirty="0">
+                <a:solidFill>
+                  <a:schemeClr val="bg1"/>
+                </a:solidFill>
+              </a:rPr>
+              <a:t>accuracy &gt;80%</a:t>
             </a:r>
           </a:p>
         </p:txBody>
@@ -9016,8 +8882,8 @@
         </p:nvSpPr>
         <p:spPr>
           <a:xfrm>
-            <a:off x="4663440" y="2057400"/>
-            <a:ext cx="2011680" cy="954107"/>
+            <a:off x="4663440" y="2207873"/>
+            <a:ext cx="2011680" cy="1069524"/>
           </a:xfrm>
           <a:prstGeom prst="rect">
             <a:avLst/>
@@ -9036,7 +8902,7 @@
               <a:spcAft>
                 <a:spcPts val="300"/>
               </a:spcAft>
-              <a:defRPr sz="900" b="1">
+              <a:defRPr sz="1400" b="1">
                 <a:solidFill>
                   <a:srgbClr val="FFFFFF"/>
                 </a:solidFill>
@@ -9044,71 +8910,59 @@
             </a:pPr>
             <a:r>
               <a:rPr sz="1100" dirty="0"/>
-              <a:t>WEEK 3: PILOT</a:t>
-            </a:r>
-          </a:p>
-          <a:p>
-            <a:pPr algn="ctr">
-              <a:spcAft>
-                <a:spcPts val="100"/>
-              </a:spcAft>
-              <a:defRPr sz="700">
-                <a:solidFill>
-                  <a:srgbClr val="FFFFFF"/>
-                </a:solidFill>
-              </a:defRPr>
-            </a:pPr>
-            <a:r>
-              <a:rPr sz="1000" dirty="0"/>
-              <a:t>CMMS ticketing + MES flags</a:t>
-            </a:r>
-          </a:p>
-          <a:p>
-            <a:pPr algn="ctr">
-              <a:spcAft>
-                <a:spcPts val="100"/>
-              </a:spcAft>
-              <a:defRPr sz="700">
-                <a:solidFill>
-                  <a:srgbClr val="FFFFFF"/>
-                </a:solidFill>
-              </a:defRPr>
-            </a:pPr>
-            <a:r>
-              <a:rPr sz="1000" dirty="0"/>
-              <a:t>Trade-Off Engine advisory</a:t>
-            </a:r>
-          </a:p>
-          <a:p>
-            <a:pPr algn="ctr">
-              <a:spcAft>
-                <a:spcPts val="100"/>
-              </a:spcAft>
-              <a:defRPr sz="700">
-                <a:solidFill>
-                  <a:srgbClr val="FFFFFF"/>
-                </a:solidFill>
-              </a:defRPr>
-            </a:pPr>
-            <a:r>
-              <a:rPr sz="1000" dirty="0"/>
-              <a:t>Expand to W2</a:t>
-            </a:r>
-          </a:p>
-          <a:p>
-            <a:pPr algn="ctr">
-              <a:spcAft>
-                <a:spcPts val="100"/>
-              </a:spcAft>
-              <a:defRPr sz="700">
-                <a:solidFill>
-                  <a:srgbClr val="FFFFFF"/>
-                </a:solidFill>
-              </a:defRPr>
-            </a:pPr>
-            <a:r>
-              <a:rPr sz="1000" dirty="0"/>
-              <a:t>GATE: Approval acceptable</a:t>
+              <a:t>WEEK 3: FOLLOW-UP</a:t>
+            </a:r>
+          </a:p>
+          <a:p>
+            <a:pPr>
+              <a:defRPr sz="1200"/>
+            </a:pPr>
+            <a:r>
+              <a:rPr sz="1000" dirty="0">
+                <a:solidFill>
+                  <a:schemeClr val="bg1"/>
+                </a:solidFill>
+              </a:rPr>
+              <a:t>Auto-contact right owner</a:t>
+            </a:r>
+          </a:p>
+          <a:p>
+            <a:pPr>
+              <a:defRPr sz="1100"/>
+            </a:pPr>
+            <a:r>
+              <a:rPr sz="1000" dirty="0">
+                <a:solidFill>
+                  <a:schemeClr val="bg1"/>
+                </a:solidFill>
+              </a:rPr>
+              <a:t>DOWNTIME → maintenance, WIP_QUEUE → planner</a:t>
+            </a:r>
+          </a:p>
+          <a:p>
+            <a:pPr>
+              <a:defRPr sz="1100"/>
+            </a:pPr>
+            <a:r>
+              <a:rPr sz="1000" dirty="0">
+                <a:solidFill>
+                  <a:schemeClr val="bg1"/>
+                </a:solidFill>
+              </a:rPr>
+              <a:t>SLA: 15-min response</a:t>
+            </a:r>
+          </a:p>
+          <a:p>
+            <a:pPr>
+              <a:defRPr sz="1100" b="1"/>
+            </a:pPr>
+            <a:r>
+              <a:rPr sz="1000" dirty="0">
+                <a:solidFill>
+                  <a:schemeClr val="bg1"/>
+                </a:solidFill>
+              </a:rPr>
+              <a:t>GATE: Response rate &gt;80%</a:t>
             </a:r>
           </a:p>
         </p:txBody>
@@ -9121,8 +8975,8 @@
         </p:nvSpPr>
         <p:spPr>
           <a:xfrm>
-            <a:off x="6858000" y="2057400"/>
-            <a:ext cx="2011680" cy="954107"/>
+            <a:off x="6858000" y="2194633"/>
+            <a:ext cx="2011680" cy="1084912"/>
           </a:xfrm>
           <a:prstGeom prst="rect">
             <a:avLst/>
@@ -9141,7 +8995,7 @@
               <a:spcAft>
                 <a:spcPts val="300"/>
               </a:spcAft>
-              <a:defRPr sz="900" b="1">
+              <a:defRPr sz="1400" b="1">
                 <a:solidFill>
                   <a:srgbClr val="FFFFFF"/>
                 </a:solidFill>
@@ -9153,67 +9007,55 @@
             </a:r>
           </a:p>
           <a:p>
-            <a:pPr algn="ctr">
-              <a:spcAft>
-                <a:spcPts val="100"/>
-              </a:spcAft>
-              <a:defRPr sz="700">
-                <a:solidFill>
-                  <a:srgbClr val="FFFFFF"/>
-                </a:solidFill>
-              </a:defRPr>
-            </a:pPr>
-            <a:r>
-              <a:rPr sz="1000" dirty="0"/>
-              <a:t>Auto-execute W1 low-risk</a:t>
-            </a:r>
-          </a:p>
-          <a:p>
-            <a:pPr algn="ctr">
-              <a:spcAft>
-                <a:spcPts val="100"/>
-              </a:spcAft>
-              <a:defRPr sz="700">
-                <a:solidFill>
-                  <a:srgbClr val="FFFFFF"/>
-                </a:solidFill>
-              </a:defRPr>
-            </a:pPr>
-            <a:r>
-              <a:rPr sz="1000" dirty="0"/>
-              <a:t>W2 hard approval gate</a:t>
-            </a:r>
-          </a:p>
-          <a:p>
-            <a:pPr algn="ctr">
-              <a:spcAft>
-                <a:spcPts val="100"/>
-              </a:spcAft>
-              <a:defRPr sz="700">
-                <a:solidFill>
-                  <a:srgbClr val="FFFFFF"/>
-                </a:solidFill>
-              </a:defRPr>
-            </a:pPr>
-            <a:r>
-              <a:rPr sz="1000" dirty="0"/>
-              <a:t>Full audit + KPI dashboard</a:t>
-            </a:r>
-          </a:p>
-          <a:p>
-            <a:pPr algn="ctr">
-              <a:spcAft>
-                <a:spcPts val="100"/>
-              </a:spcAft>
-              <a:defRPr sz="700">
-                <a:solidFill>
-                  <a:srgbClr val="FFFFFF"/>
-                </a:solidFill>
-              </a:defRPr>
-            </a:pPr>
-            <a:r>
-              <a:rPr sz="1000" dirty="0"/>
-              <a:t>GATE: OTIF improve</a:t>
+            <a:pPr>
+              <a:defRPr sz="1100"/>
+            </a:pPr>
+            <a:r>
+              <a:rPr sz="1000" dirty="0">
+                <a:solidFill>
+                  <a:schemeClr val="bg1"/>
+                </a:solidFill>
+              </a:rPr>
+              <a:t>Trade-Off Engine + CMMS + MES flags</a:t>
+            </a:r>
+          </a:p>
+          <a:p>
+            <a:pPr>
+              <a:defRPr sz="1100"/>
+            </a:pPr>
+            <a:r>
+              <a:rPr sz="1000" dirty="0">
+                <a:solidFill>
+                  <a:schemeClr val="bg1"/>
+                </a:solidFill>
+              </a:rPr>
+              <a:t>Auto-execute low-risk (flag, ticket)</a:t>
+            </a:r>
+          </a:p>
+          <a:p>
+            <a:pPr>
+              <a:defRPr sz="1100"/>
+            </a:pPr>
+            <a:r>
+              <a:rPr sz="1000" dirty="0">
+                <a:solidFill>
+                  <a:schemeClr val="bg1"/>
+                </a:solidFill>
+              </a:rPr>
+              <a:t>Approval for high-risk (expedite)</a:t>
+            </a:r>
+          </a:p>
+          <a:p>
+            <a:pPr>
+              <a:defRPr sz="1100" b="1"/>
+            </a:pPr>
+            <a:r>
+              <a:rPr sz="1000" dirty="0">
+                <a:solidFill>
+                  <a:schemeClr val="bg1"/>
+                </a:solidFill>
+              </a:rPr>
+              <a:t>GATE: OTIF improve + low FP</a:t>
             </a:r>
           </a:p>
         </p:txBody>
@@ -9226,7 +9068,7 @@
         </p:nvSpPr>
         <p:spPr>
           <a:xfrm>
-            <a:off x="274320" y="3182000"/>
+            <a:off x="274320" y="3340794"/>
             <a:ext cx="4114800" cy="1354217"/>
           </a:xfrm>
           <a:prstGeom prst="rect">
@@ -9271,15 +9113,7 @@
             </a:pPr>
             <a:r>
               <a:rPr sz="1000" dirty="0"/>
-              <a:t>• Docker + K8s: Agent containers, </a:t>
-            </a:r>
-            <a:r>
-              <a:rPr sz="1000" dirty="0" err="1"/>
-              <a:t>API</a:t>
-            </a:r>
-            <a:r>
-              <a:rPr sz="1000" dirty="0"/>
-              <a:t>, Celery workers</a:t>
+              <a:t>• Docker + K8s: Agent containers, API, Celery workers</a:t>
             </a:r>
           </a:p>
           <a:p>
@@ -9303,15 +9137,19 @@
             </a:pPr>
             <a:r>
               <a:rPr sz="1000" dirty="0"/>
-              <a:t>• Vector DB: Vector DB/</a:t>
-            </a:r>
-            <a:r>
-              <a:rPr sz="1000" dirty="0" err="1"/>
-              <a:t>Weaviate</a:t>
-            </a:r>
+              <a:t>• Vector DB: Vector DB/Weaviate | LLM provider embeddings</a:t>
+            </a:r>
+          </a:p>
+          <a:p>
+            <a:pPr>
+              <a:spcAft>
+                <a:spcPts val="200"/>
+              </a:spcAft>
+              <a:defRPr sz="700"/>
+            </a:pPr>
             <a:r>
               <a:rPr sz="1000" dirty="0"/>
-              <a:t> | LLM provider embeddings</a:t>
+              <a:t>• PostgreSQL: TimescaleDB, Primary + 2 replicas</a:t>
             </a:r>
           </a:p>
           <a:p>
@@ -9323,55 +9161,19 @@
             </a:pPr>
             <a:r>
               <a:rPr sz="1000" dirty="0"/>
-              <a:t>• PostgreSQL: </a:t>
-            </a:r>
-            <a:r>
-              <a:rPr sz="1000" dirty="0" err="1"/>
-              <a:t>TimescaleDB</a:t>
-            </a:r>
+              <a:t>• Observability: LangSmith, Prometheus, Grafana, ELK</a:t>
+            </a:r>
+          </a:p>
+          <a:p>
+            <a:pPr>
+              <a:spcAft>
+                <a:spcPts val="200"/>
+              </a:spcAft>
+              <a:defRPr sz="700"/>
+            </a:pPr>
             <a:r>
               <a:rPr sz="1000" dirty="0"/>
-              <a:t>, Primary + 2 replicas</a:t>
-            </a:r>
-          </a:p>
-          <a:p>
-            <a:pPr>
-              <a:spcAft>
-                <a:spcPts val="200"/>
-              </a:spcAft>
-              <a:defRPr sz="700"/>
-            </a:pPr>
-            <a:r>
-              <a:rPr sz="1000" dirty="0"/>
-              <a:t>• Observability: </a:t>
-            </a:r>
-            <a:r>
-              <a:rPr sz="1000" dirty="0" err="1"/>
-              <a:t>LangSmith</a:t>
-            </a:r>
-            <a:r>
-              <a:rPr sz="1000" dirty="0"/>
-              <a:t>, Prometheus, Grafana, ELK</a:t>
-            </a:r>
-          </a:p>
-          <a:p>
-            <a:pPr>
-              <a:spcAft>
-                <a:spcPts val="200"/>
-              </a:spcAft>
-              <a:defRPr sz="700"/>
-            </a:pPr>
-            <a:r>
-              <a:rPr sz="1000" dirty="0"/>
-              <a:t>• CI/CD: GitHub Actions → </a:t>
-            </a:r>
-            <a:r>
-              <a:rPr sz="1000" dirty="0" err="1"/>
-              <a:t>ArgoCD</a:t>
-            </a:r>
-            <a:r>
-              <a:rPr sz="1000" dirty="0"/>
-              <a:t> → EKS</a:t>
+              <a:t>• CI/CD: GitHub Actions → ArgoCD → EKS</a:t>
             </a:r>
           </a:p>
         </p:txBody>
@@ -9384,7 +9186,7 @@
         </p:nvSpPr>
         <p:spPr>
           <a:xfrm>
-            <a:off x="4572000" y="3180687"/>
+            <a:off x="4564049" y="3337355"/>
             <a:ext cx="4297680" cy="1290097"/>
           </a:xfrm>
           <a:prstGeom prst="rect">
@@ -9441,23 +9243,7 @@
             </a:pPr>
             <a:r>
               <a:rPr sz="1000" dirty="0"/>
-              <a:t>  </a:t>
-            </a:r>
-            <a:r>
-              <a:rPr sz="1000" dirty="0" err="1"/>
-              <a:t>pytest</a:t>
-            </a:r>
-            <a:r>
-              <a:rPr sz="1000" dirty="0"/>
-              <a:t> + mock | hypothesis | </a:t>
-            </a:r>
-            <a:r>
-              <a:rPr sz="1000" dirty="0" err="1"/>
-              <a:t>Pydantic</a:t>
-            </a:r>
-            <a:r>
-              <a:rPr sz="1000" dirty="0"/>
-              <a:t> | Not isolation | Coverage high</a:t>
+              <a:t>  pytest + mock | hypothesis | Pydantic | Not isolation | Coverage high</a:t>
             </a:r>
           </a:p>
           <a:p>
@@ -9481,23 +9267,7 @@
             </a:pPr>
             <a:r>
               <a:rPr sz="1000" dirty="0"/>
-              <a:t>  </a:t>
-            </a:r>
-            <a:r>
-              <a:rPr sz="1000" dirty="0" err="1"/>
-              <a:t>TestContainers</a:t>
-            </a:r>
-            <a:r>
-              <a:rPr sz="1000" dirty="0"/>
-              <a:t>: Kafka + PostgreSQL | </a:t>
-            </a:r>
-            <a:r>
-              <a:rPr sz="1000" dirty="0" err="1"/>
-              <a:t>LangGraph</a:t>
-            </a:r>
-            <a:r>
-              <a:rPr sz="1000" dirty="0"/>
-              <a:t> transitions | API contracts</a:t>
+              <a:t>  TestContainers: Kafka + PostgreSQL | LangGraph transitions | API contracts</a:t>
             </a:r>
           </a:p>
           <a:p>
@@ -9521,15 +9291,7 @@
             </a:pPr>
             <a:r>
               <a:rPr sz="1000" dirty="0"/>
-              <a:t>  </a:t>
-            </a:r>
-            <a:r>
-              <a:rPr sz="1000" dirty="0" err="1"/>
-              <a:t>LangSmith</a:t>
-            </a:r>
-            <a:r>
-              <a:rPr sz="1000" dirty="0"/>
-              <a:t>: 500 incidents | LLM-as-judge | Known-good trade-offs</a:t>
+              <a:t>  LangSmith: 500 incidents | LLM-as-judge | Known-good trade-offs</a:t>
             </a:r>
           </a:p>
         </p:txBody>
@@ -9542,8 +9304,8 @@
         </p:nvSpPr>
         <p:spPr>
           <a:xfrm>
-            <a:off x="274320" y="4620769"/>
-            <a:ext cx="4114800" cy="1808187"/>
+            <a:off x="1454191" y="4689856"/>
+            <a:ext cx="5625036" cy="456535"/>
           </a:xfrm>
           <a:prstGeom prst="rect">
             <a:avLst/>
@@ -9585,92 +9347,14 @@
               </a:spcAft>
               <a:defRPr sz="700"/>
             </a:pPr>
-            <a:endParaRPr sz="1200" dirty="0"/>
-          </a:p>
-          <a:p>
-            <a:pPr>
-              <a:spcAft>
-                <a:spcPts val="100"/>
-              </a:spcAft>
-              <a:defRPr sz="700"/>
-            </a:pPr>
-            <a:r>
-              <a:rPr sz="1000" dirty="0"/>
-              <a:t>Kafka (Managed Kafka) infrastructure cost | Planner time: time saved per planner</a:t>
-            </a:r>
-          </a:p>
-          <a:p>
-            <a:pPr>
-              <a:spcAft>
-                <a:spcPts val="100"/>
-              </a:spcAft>
-              <a:defRPr sz="700"/>
-            </a:pPr>
-            <a:r>
-              <a:rPr sz="1000" dirty="0"/>
-              <a:t>System pays for itself in one quarter | LLM API variable cost</a:t>
-            </a:r>
-          </a:p>
-          <a:p>
-            <a:pPr>
-              <a:spcAft>
-                <a:spcPts val="100"/>
-              </a:spcAft>
-              <a:defRPr sz="700"/>
-            </a:pPr>
-            <a:r>
-              <a:rPr sz="1000" dirty="0"/>
-              <a:t>Vector DB storage cost | </a:t>
-            </a:r>
-          </a:p>
-          <a:p>
-            <a:pPr>
-              <a:spcAft>
-                <a:spcPts val="100"/>
-              </a:spcAft>
-              <a:defRPr sz="700"/>
-            </a:pPr>
-            <a:r>
-              <a:rPr sz="1000" dirty="0"/>
-              <a:t>Observability (</a:t>
-            </a:r>
-            <a:r>
-              <a:rPr sz="1000" dirty="0" err="1"/>
-              <a:t>LangSmith</a:t>
-            </a:r>
-            <a:r>
-              <a:rPr sz="1000" dirty="0"/>
-              <a:t>, ELK) monitoring cost</a:t>
-            </a:r>
-          </a:p>
-          <a:p>
-            <a:pPr>
-              <a:spcAft>
-                <a:spcPts val="100"/>
-              </a:spcAft>
-              <a:defRPr sz="700"/>
-            </a:pPr>
-            <a:endParaRPr sz="1000" dirty="0"/>
-          </a:p>
-          <a:p>
-            <a:pPr>
-              <a:spcAft>
-                <a:spcPts val="100"/>
-              </a:spcAft>
-              <a:defRPr sz="700"/>
-            </a:pPr>
             <a:r>
               <a:rPr sz="1000" dirty="0"/>
               <a:t>ROI: Reduced expedites, improved OTIF, planner time saved</a:t>
             </a:r>
-          </a:p>
-          <a:p>
-            <a:pPr>
-              <a:spcAft>
-                <a:spcPts val="100"/>
-              </a:spcAft>
-              <a:defRPr sz="700"/>
-            </a:pPr>
+            <a:r>
+              <a:rPr lang="en-US" sz="1000" dirty="0"/>
+              <a:t>  </a:t>
+            </a:r>
             <a:r>
               <a:rPr sz="1000" dirty="0"/>
               <a:t>(Avoid one W1 shortage → significant value)</a:t>
@@ -9686,8 +9370,8 @@
         </p:nvSpPr>
         <p:spPr>
           <a:xfrm>
-            <a:off x="4572000" y="4620769"/>
-            <a:ext cx="4297680" cy="1354217"/>
+            <a:off x="1454192" y="5216223"/>
+            <a:ext cx="5625035" cy="1354217"/>
           </a:xfrm>
           <a:prstGeom prst="rect">
             <a:avLst/>
@@ -9729,15 +9413,7 @@
             </a:pPr>
             <a:r>
               <a:rPr sz="1000" dirty="0"/>
-              <a:t>1. </a:t>
-            </a:r>
-            <a:r>
-              <a:rPr sz="1000" dirty="0" err="1"/>
-              <a:t>LangGraph</a:t>
-            </a:r>
-            <a:r>
-              <a:rPr sz="1000" dirty="0"/>
-              <a:t> over Airflow: Cyclic workflows (follow-up loops)</a:t>
+              <a:t>1. LangGraph over Airflow: Cyclic workflows (follow-up loops)</a:t>
             </a:r>
           </a:p>
           <a:p>

</xml_diff>